<commit_message>
Second cycle: categories become sub-headings with separate points; each point answers its sub-heading
LSA Geography of Cameroon L1-L15, Meteorology L16-L18, Climatology FS1,
Geomorphology L9 and L15, USA Population L1-L18 and PW1-PW4, USA
statistics QT2-QT4: causes, effects, factors, threats and measures,
advantages and disadvantages are now sub-headings, each item explained
in 2-3 sentences; L11 and L12 (demographic explosion, DTM) rewritten so
that every point matches its heading. Rule added to REGLES_DES_LECONS.md.

Co-Authored-By: Claude Opus 5.5 <noreply@anthropic.com>
Claude-Session: https://claude.ai/code/session_0115LFSb2ktGLWPeVksFkSer
</commit_message>
<xml_diff>
--- a/lecons/LSA/Meteorology/18_LSA_MET_L18_Air_Masses.pptx
+++ b/lecons/LSA/Meteorology/18_LSA_MET_L18_Air_Masses.pptx
@@ -70,9 +70,12 @@
     <p:sldId id="318" r:id="rId64"/>
     <p:sldId id="319" r:id="rId65"/>
     <p:sldId id="320" r:id="rId66"/>
+    <p:sldId id="321" r:id="rId67"/>
+    <p:sldId id="322" r:id="rId68"/>
+    <p:sldId id="323" r:id="rId69"/>
   </p:sldIdLst>
   <p:notesMasterIdLst>
-    <p:notesMasterId r:id="rId67"/>
+    <p:notesMasterId r:id="rId70"/>
   </p:notesMasterIdLst>
   <p:sldSz cx="12192000" cy="6858000"/>
   <p:notesSz cx="6858000" cy="12192000"/>
@@ -3998,7 +4001,7 @@
           <a:p>
             <a:r>
               <a:rPr lang="en-US" dirty="0"/>
-              <a:t>Let us copy Classification and Examples. Air masses are classified with two letters as follows. Copy the point on First letter (humidity): write the key term first, then its explanation.</a:t>
+              <a:t>Let us copy The Two Letters. Air masses are classified with two letters as follows. Copy the point on First letter (humidity): write the key term first, then its explanation.</a:t>
             </a:r>
             <a:endParaRPr lang="en-US" dirty="0"/>
           </a:p>
@@ -4174,7 +4177,7 @@
           <a:p>
             <a:r>
               <a:rPr lang="en-US" dirty="0"/>
-              <a:t>We continue with Classification and Examples. Copy the point on Examples: write the key term first, then its explanation.</a:t>
+              <a:t>Let us copy Examples. The main air masses are the following. Copy the point on Tropical continental (cT): write the key term first, then its explanation.</a:t>
             </a:r>
             <a:endParaRPr lang="en-US" dirty="0"/>
           </a:p>
@@ -4262,7 +4265,7 @@
           <a:p>
             <a:r>
               <a:rPr lang="en-US" dirty="0"/>
-              <a:t>Let us copy Types and Movements of Air Masses. Air masses are of the following types and move as follows. Copy the point on Warm air masses: write the key term first, then its explanation.</a:t>
+              <a:t>We continue with Examples. Copy the point on Tropical maritime (mT): write the key term first, then its explanation.</a:t>
             </a:r>
             <a:endParaRPr lang="en-US" dirty="0"/>
           </a:p>
@@ -4350,7 +4353,7 @@
           <a:p>
             <a:r>
               <a:rPr lang="en-US" dirty="0"/>
-              <a:t>We continue with Types and Movements of Air Masses. Copy the point on Cold air masses: write the key term first, then its explanation.</a:t>
+              <a:t>We continue with Examples. Copy the point on Polar continental (cP): write the key term first, then its explanation.</a:t>
             </a:r>
             <a:endParaRPr lang="en-US" dirty="0"/>
           </a:p>
@@ -4526,7 +4529,7 @@
           <a:p>
             <a:r>
               <a:rPr lang="en-US" dirty="0"/>
-              <a:t>We continue with Types and Movements of Air Masses. Copy the point on Seasonal movement: write the key term first, then its explanation.</a:t>
+              <a:t>We continue with Examples. Copy the point on Polar maritime (mP): write the key term first, then its explanation.</a:t>
             </a:r>
             <a:endParaRPr lang="en-US" dirty="0"/>
           </a:p>
@@ -4614,7 +4617,7 @@
           <a:p>
             <a:r>
               <a:rPr lang="en-US" dirty="0"/>
-              <a:t>Let us copy Air Masses Affecting Cameroon and West Africa. Two air masses control the seasons of Cameroon as follows. Copy the point on Tropical continental air (cT) on the left, then draw the diagram on the right: the Harmattan. Give it a title and label it clearly.</a:t>
+              <a:t>Let us copy Types and Movements of Air Masses. Air masses are of the following types and move as follows. Copy the point on Warm air masses: write the key term first, then its explanation.</a:t>
             </a:r>
             <a:endParaRPr lang="en-US" dirty="0"/>
           </a:p>
@@ -4702,7 +4705,7 @@
           <a:p>
             <a:r>
               <a:rPr lang="en-US" dirty="0"/>
-              <a:t>Copy the point on Tropical maritime air (mT) on the left, then draw the diagram on the right: heavy rain. Give it a title and label it clearly.</a:t>
+              <a:t>We continue with Types and Movements of Air Masses. Copy the point on Cold air masses: write the key term first, then its explanation.</a:t>
             </a:r>
             <a:endParaRPr lang="en-US" dirty="0"/>
           </a:p>
@@ -4790,7 +4793,7 @@
           <a:p>
             <a:r>
               <a:rPr lang="en-US" dirty="0"/>
-              <a:t>Copy the point on The Intertropical Front (ITF) on the left, then draw the diagram on the right: the air masses of West Africa. Give it a title and label it clearly.</a:t>
+              <a:t>We continue with Types and Movements of Air Masses. Copy the point on Seasonal movement: write the key term first, then its explanation.</a:t>
             </a:r>
             <a:endParaRPr lang="en-US" dirty="0"/>
           </a:p>
@@ -4878,7 +4881,7 @@
           <a:p>
             <a:r>
               <a:rPr lang="en-US" dirty="0"/>
-              <a:t>Now let us check what you have understood. Question 1: Distinguish a continental air mass from a maritime air mass. Answer in your exercise book.</a:t>
+              <a:t>Let us copy Air Masses Affecting Cameroon and West Africa. Two air masses control the seasons of Cameroon as follows. Copy the point on Tropical continental air (cT) on the left, then draw the diagram on the right: the Harmattan. Give it a title and label it clearly.</a:t>
             </a:r>
             <a:endParaRPr lang="en-US" dirty="0"/>
           </a:p>
@@ -4966,7 +4969,7 @@
           <a:p>
             <a:r>
               <a:rPr lang="en-US" dirty="0"/>
-              <a:t>The expected answer is: a continental air mass forms over land and is dry; a maritime air mass forms over the sea and is moist. If you got it right, well done.</a:t>
+              <a:t>Copy the point on Tropical maritime air (mT) on the left, then draw the diagram on the right: heavy rain. Give it a title and label it clearly.</a:t>
             </a:r>
             <a:endParaRPr lang="en-US" dirty="0"/>
           </a:p>
@@ -5054,7 +5057,7 @@
           <a:p>
             <a:r>
               <a:rPr lang="en-US" dirty="0"/>
-              <a:t>Now let us check what you have understood. Question 2: Which air mass brings the rainy season to Garoua, and why? Answer in your exercise book.</a:t>
+              <a:t>Copy the point on The Intertropical Front (ITF) on the left, then draw the diagram on the right: the air masses of West Africa. Give it a title and label it clearly.</a:t>
             </a:r>
             <a:endParaRPr lang="en-US" dirty="0"/>
           </a:p>
@@ -5142,7 +5145,7 @@
           <a:p>
             <a:r>
               <a:rPr lang="en-US" dirty="0"/>
-              <a:t>The expected answer is: the tropical maritime (mT) air mass, because it is moist and unstable. If you got it right, well done.</a:t>
+              <a:t>Now let us check what you have understood. Question 1: Distinguish a continental air mass from a maritime air mass. Answer in your exercise book.</a:t>
             </a:r>
             <a:endParaRPr lang="en-US" dirty="0"/>
           </a:p>
@@ -5230,7 +5233,7 @@
           <a:p>
             <a:r>
               <a:rPr lang="en-US" dirty="0"/>
-              <a:t>For those who need more practice, fill in the blanks in your exercise book. The answers are: number 1, source; number 2, tropical continental (cT); number 3, Intertropical Front (ITF).</a:t>
+              <a:t>The expected answer is: a continental air mass forms over land and is dry; a maritime air mass forms over the sea and is moist. If you got it right, well done.</a:t>
             </a:r>
             <a:endParaRPr lang="en-US" dirty="0"/>
           </a:p>
@@ -5318,7 +5321,7 @@
           <a:p>
             <a:r>
               <a:rPr lang="en-US" dirty="0"/>
-              <a:t>For your homework: Define climate. We shall correct it at the beginning of our next lesson.</a:t>
+              <a:t>Now let us check what you have understood. Question 2: Which air mass brings the rainy season to Garoua, and why? Answer in your exercise book.</a:t>
             </a:r>
             <a:endParaRPr lang="en-US" dirty="0"/>
           </a:p>
@@ -5494,7 +5497,7 @@
           <a:p>
             <a:r>
               <a:rPr lang="en-US" dirty="0"/>
-              <a:t>Our next lesson will be on Lesson 19: Meaning of Climate and Köppen's Classification. Thank you for your attention, and see you next time.</a:t>
+              <a:t>The expected answer is: the tropical maritime (mT) air mass, because it is moist and unstable. If you got it right, well done.</a:t>
             </a:r>
             <a:endParaRPr lang="en-US" dirty="0"/>
           </a:p>
@@ -5582,7 +5585,7 @@
           <a:p>
             <a:r>
               <a:rPr lang="en-US" dirty="0"/>
-              <a:t>Let us play the bilingual game. I say a word in English, and you give me the French word. Then we do the reverse.</a:t>
+              <a:t>For those who need more practice, fill in the blanks in your exercise book. The answers are: number 1, source; number 2, tropical continental (cT); number 3, Intertropical Front (ITF).</a:t>
             </a:r>
             <a:endParaRPr lang="en-US" dirty="0"/>
           </a:p>
@@ -5670,7 +5673,7 @@
           <a:p>
             <a:r>
               <a:rPr lang="en-US" dirty="0"/>
-              <a:t>I record this information in the official logbook of the class after the lesson.</a:t>
+              <a:t>For your homework: Define climate. We shall correct it at the beginning of our next lesson.</a:t>
             </a:r>
             <a:endParaRPr lang="en-US" dirty="0"/>
           </a:p>
@@ -5758,7 +5761,7 @@
           <a:p>
             <a:r>
               <a:rPr lang="en-US" dirty="0"/>
-              <a:t>I complete the second page of the logbook: the matter taught, the evaluation, the homework and the attendance.</a:t>
+              <a:t>Our next lesson will be on Lesson 19: Meaning of Climate and Köppen's Classification. Thank you for your attention, and see you next time.</a:t>
             </a:r>
             <a:endParaRPr lang="en-US" dirty="0"/>
           </a:p>
@@ -5846,7 +5849,7 @@
           <a:p>
             <a:r>
               <a:rPr lang="en-US" dirty="0"/>
-              <a:t>This slide is for me, the teacher: it gives the timing of the lesson and what to do if the projector is not available.</a:t>
+              <a:t>Let us play the bilingual game. I say a word in English, and you give me the French word. Then we do the reverse.</a:t>
             </a:r>
             <a:endParaRPr lang="en-US" dirty="0"/>
           </a:p>
@@ -5934,7 +5937,7 @@
           <a:p>
             <a:r>
               <a:rPr lang="en-US" dirty="0"/>
-              <a:t>These are the references and picture credits used to prepare this lesson.</a:t>
+              <a:t>I record this information in the official logbook of the class after the lesson.</a:t>
             </a:r>
             <a:endParaRPr lang="en-US" dirty="0"/>
           </a:p>
@@ -5958,6 +5961,270 @@
             <a:fld id="{F7021451-1387-4CA6-816F-3879F97B5CBC}" type="slidenum">
               <a:rPr lang="en-US"/>
               <a:t>65</a:t>
+            </a:fld>
+            <a:endParaRPr lang="en-US"/>
+          </a:p>
+        </p:txBody>
+      </p:sp>
+    </p:spTree>
+    <p:extLst>
+      <p:ext uri="{BB962C8B-B14F-4D97-AF65-F5344CB8AC3E}">
+        <p14:creationId xmlns:p14="http://schemas.microsoft.com/office/powerpoint/2010/main" val="1024086991"/>
+      </p:ext>
+    </p:extLst>
+  </p:cSld>
+  <p:clrMapOvr>
+    <a:masterClrMapping/>
+  </p:clrMapOvr>
+</p:notes>
+</file>
+
+<file path=ppt/notesSlides/notesSlide66.xml><?xml version="1.0" encoding="utf-8"?>
+<p:notes xmlns:a="http://schemas.openxmlformats.org/drawingml/2006/main" xmlns:r="http://schemas.openxmlformats.org/officeDocument/2006/relationships" xmlns:p="http://schemas.openxmlformats.org/presentationml/2006/main">
+  <p:cSld>
+    <p:spTree>
+      <p:nvGrpSpPr>
+        <p:cNvPr id="1" name=""/>
+        <p:cNvGrpSpPr/>
+        <p:nvPr/>
+      </p:nvGrpSpPr>
+      <p:grpSpPr>
+        <a:xfrm>
+          <a:off x="0" y="0"/>
+          <a:ext cx="0" cy="0"/>
+          <a:chOff x="0" y="0"/>
+          <a:chExt cx="0" cy="0"/>
+        </a:xfrm>
+      </p:grpSpPr>
+      <p:sp>
+        <p:nvSpPr>
+          <p:cNvPr id="2" name="Slide Image Placeholder 1"/>
+          <p:cNvSpPr>
+            <a:spLocks noGrp="1" noRot="1" noChangeAspect="1"/>
+          </p:cNvSpPr>
+          <p:nvPr>
+            <p:ph type="sldImg"/>
+          </p:nvPr>
+        </p:nvSpPr>
+        <p:spPr/>
+      </p:sp>
+      <p:sp>
+        <p:nvSpPr>
+          <p:cNvPr id="3" name="Notes Placeholder 2"/>
+          <p:cNvSpPr>
+            <a:spLocks noGrp="1"/>
+          </p:cNvSpPr>
+          <p:nvPr>
+            <p:ph type="body" idx="1"/>
+          </p:nvPr>
+        </p:nvSpPr>
+        <p:spPr/>
+        <p:txBody>
+          <a:bodyPr/>
+          <a:lstStyle/>
+          <a:p>
+            <a:r>
+              <a:rPr lang="en-US" dirty="0"/>
+              <a:t>I complete the second page of the logbook: the matter taught, the evaluation, the homework and the attendance.</a:t>
+            </a:r>
+            <a:endParaRPr lang="en-US" dirty="0"/>
+          </a:p>
+        </p:txBody>
+      </p:sp>
+      <p:sp>
+        <p:nvSpPr>
+          <p:cNvPr id="4" name="Slide Number Placeholder 3"/>
+          <p:cNvSpPr>
+            <a:spLocks noGrp="1"/>
+          </p:cNvSpPr>
+          <p:nvPr>
+            <p:ph type="sldNum" sz="quarter" idx="10"/>
+          </p:nvPr>
+        </p:nvSpPr>
+        <p:spPr/>
+        <p:txBody>
+          <a:bodyPr/>
+          <a:lstStyle/>
+          <a:p>
+            <a:fld id="{F7021451-1387-4CA6-816F-3879F97B5CBC}" type="slidenum">
+              <a:rPr lang="en-US"/>
+              <a:t>66</a:t>
+            </a:fld>
+            <a:endParaRPr lang="en-US"/>
+          </a:p>
+        </p:txBody>
+      </p:sp>
+    </p:spTree>
+    <p:extLst>
+      <p:ext uri="{BB962C8B-B14F-4D97-AF65-F5344CB8AC3E}">
+        <p14:creationId xmlns:p14="http://schemas.microsoft.com/office/powerpoint/2010/main" val="1024086991"/>
+      </p:ext>
+    </p:extLst>
+  </p:cSld>
+  <p:clrMapOvr>
+    <a:masterClrMapping/>
+  </p:clrMapOvr>
+</p:notes>
+</file>
+
+<file path=ppt/notesSlides/notesSlide67.xml><?xml version="1.0" encoding="utf-8"?>
+<p:notes xmlns:a="http://schemas.openxmlformats.org/drawingml/2006/main" xmlns:r="http://schemas.openxmlformats.org/officeDocument/2006/relationships" xmlns:p="http://schemas.openxmlformats.org/presentationml/2006/main">
+  <p:cSld>
+    <p:spTree>
+      <p:nvGrpSpPr>
+        <p:cNvPr id="1" name=""/>
+        <p:cNvGrpSpPr/>
+        <p:nvPr/>
+      </p:nvGrpSpPr>
+      <p:grpSpPr>
+        <a:xfrm>
+          <a:off x="0" y="0"/>
+          <a:ext cx="0" cy="0"/>
+          <a:chOff x="0" y="0"/>
+          <a:chExt cx="0" cy="0"/>
+        </a:xfrm>
+      </p:grpSpPr>
+      <p:sp>
+        <p:nvSpPr>
+          <p:cNvPr id="2" name="Slide Image Placeholder 1"/>
+          <p:cNvSpPr>
+            <a:spLocks noGrp="1" noRot="1" noChangeAspect="1"/>
+          </p:cNvSpPr>
+          <p:nvPr>
+            <p:ph type="sldImg"/>
+          </p:nvPr>
+        </p:nvSpPr>
+        <p:spPr/>
+      </p:sp>
+      <p:sp>
+        <p:nvSpPr>
+          <p:cNvPr id="3" name="Notes Placeholder 2"/>
+          <p:cNvSpPr>
+            <a:spLocks noGrp="1"/>
+          </p:cNvSpPr>
+          <p:nvPr>
+            <p:ph type="body" idx="1"/>
+          </p:nvPr>
+        </p:nvSpPr>
+        <p:spPr/>
+        <p:txBody>
+          <a:bodyPr/>
+          <a:lstStyle/>
+          <a:p>
+            <a:r>
+              <a:rPr lang="en-US" dirty="0"/>
+              <a:t>This slide is for me, the teacher: it gives the timing of the lesson and what to do if the projector is not available.</a:t>
+            </a:r>
+            <a:endParaRPr lang="en-US" dirty="0"/>
+          </a:p>
+        </p:txBody>
+      </p:sp>
+      <p:sp>
+        <p:nvSpPr>
+          <p:cNvPr id="4" name="Slide Number Placeholder 3"/>
+          <p:cNvSpPr>
+            <a:spLocks noGrp="1"/>
+          </p:cNvSpPr>
+          <p:nvPr>
+            <p:ph type="sldNum" sz="quarter" idx="10"/>
+          </p:nvPr>
+        </p:nvSpPr>
+        <p:spPr/>
+        <p:txBody>
+          <a:bodyPr/>
+          <a:lstStyle/>
+          <a:p>
+            <a:fld id="{F7021451-1387-4CA6-816F-3879F97B5CBC}" type="slidenum">
+              <a:rPr lang="en-US"/>
+              <a:t>67</a:t>
+            </a:fld>
+            <a:endParaRPr lang="en-US"/>
+          </a:p>
+        </p:txBody>
+      </p:sp>
+    </p:spTree>
+    <p:extLst>
+      <p:ext uri="{BB962C8B-B14F-4D97-AF65-F5344CB8AC3E}">
+        <p14:creationId xmlns:p14="http://schemas.microsoft.com/office/powerpoint/2010/main" val="1024086991"/>
+      </p:ext>
+    </p:extLst>
+  </p:cSld>
+  <p:clrMapOvr>
+    <a:masterClrMapping/>
+  </p:clrMapOvr>
+</p:notes>
+</file>
+
+<file path=ppt/notesSlides/notesSlide68.xml><?xml version="1.0" encoding="utf-8"?>
+<p:notes xmlns:a="http://schemas.openxmlformats.org/drawingml/2006/main" xmlns:r="http://schemas.openxmlformats.org/officeDocument/2006/relationships" xmlns:p="http://schemas.openxmlformats.org/presentationml/2006/main">
+  <p:cSld>
+    <p:spTree>
+      <p:nvGrpSpPr>
+        <p:cNvPr id="1" name=""/>
+        <p:cNvGrpSpPr/>
+        <p:nvPr/>
+      </p:nvGrpSpPr>
+      <p:grpSpPr>
+        <a:xfrm>
+          <a:off x="0" y="0"/>
+          <a:ext cx="0" cy="0"/>
+          <a:chOff x="0" y="0"/>
+          <a:chExt cx="0" cy="0"/>
+        </a:xfrm>
+      </p:grpSpPr>
+      <p:sp>
+        <p:nvSpPr>
+          <p:cNvPr id="2" name="Slide Image Placeholder 1"/>
+          <p:cNvSpPr>
+            <a:spLocks noGrp="1" noRot="1" noChangeAspect="1"/>
+          </p:cNvSpPr>
+          <p:nvPr>
+            <p:ph type="sldImg"/>
+          </p:nvPr>
+        </p:nvSpPr>
+        <p:spPr/>
+      </p:sp>
+      <p:sp>
+        <p:nvSpPr>
+          <p:cNvPr id="3" name="Notes Placeholder 2"/>
+          <p:cNvSpPr>
+            <a:spLocks noGrp="1"/>
+          </p:cNvSpPr>
+          <p:nvPr>
+            <p:ph type="body" idx="1"/>
+          </p:nvPr>
+        </p:nvSpPr>
+        <p:spPr/>
+        <p:txBody>
+          <a:bodyPr/>
+          <a:lstStyle/>
+          <a:p>
+            <a:r>
+              <a:rPr lang="en-US" dirty="0"/>
+              <a:t>These are the references and picture credits used to prepare this lesson.</a:t>
+            </a:r>
+            <a:endParaRPr lang="en-US" dirty="0"/>
+          </a:p>
+        </p:txBody>
+      </p:sp>
+      <p:sp>
+        <p:nvSpPr>
+          <p:cNvPr id="4" name="Slide Number Placeholder 3"/>
+          <p:cNvSpPr>
+            <a:spLocks noGrp="1"/>
+          </p:cNvSpPr>
+          <p:nvPr>
+            <p:ph type="sldNum" sz="quarter" idx="10"/>
+          </p:nvPr>
+        </p:nvSpPr>
+        <p:spPr/>
+        <p:txBody>
+          <a:bodyPr/>
+          <a:lstStyle/>
+          <a:p>
+            <a:fld id="{F7021451-1387-4CA6-816F-3879F97B5CBC}" type="slidenum">
+              <a:rPr lang="en-US"/>
+              <a:t>68</a:t>
             </a:fld>
             <a:endParaRPr lang="en-US"/>
           </a:p>
@@ -17430,7 +17697,7 @@
         <p:spPr>
           <a:xfrm>
             <a:off x="0" y="658368"/>
-            <a:ext cx="1463040" cy="5833872"/>
+            <a:ext cx="2468880" cy="5833872"/>
           </a:xfrm>
           <a:prstGeom prst="rect">
             <a:avLst/>
@@ -17445,8 +17712,8 @@
         </p:nvSpPr>
         <p:spPr>
           <a:xfrm>
-            <a:off x="1691640" y="1005840"/>
-            <a:ext cx="10180015" cy="731520"/>
+            <a:off x="2697480" y="1005840"/>
+            <a:ext cx="9174175" cy="731520"/>
           </a:xfrm>
           <a:prstGeom prst="rect">
             <a:avLst/>
@@ -17486,8 +17753,47 @@
         </p:nvSpPr>
         <p:spPr>
           <a:xfrm>
-            <a:off x="1691640" y="1783080"/>
-            <a:ext cx="10180015" cy="4663440"/>
+            <a:off x="2697480" y="1737360"/>
+            <a:ext cx="9174175" cy="457200"/>
+          </a:xfrm>
+          <a:prstGeom prst="rect">
+            <a:avLst/>
+          </a:prstGeom>
+          <a:noFill/>
+          <a:ln/>
+        </p:spPr>
+        <p:txBody>
+          <a:bodyPr wrap="square" lIns="0" tIns="0" rIns="0" bIns="0" rtlCol="0" anchor="ctr"/>
+          <a:lstStyle/>
+          <a:p>
+            <a:pPr algn="l" indent="0" marL="0">
+              <a:buNone/>
+            </a:pPr>
+            <a:r>
+              <a:rPr lang="en-US" sz="3200" b="1" dirty="0">
+                <a:solidFill>
+                  <a:srgbClr val="990011"/>
+                </a:solidFill>
+                <a:latin typeface="Times New Roman" pitchFamily="34" charset="0"/>
+                <a:ea typeface="Times New Roman" pitchFamily="34" charset="-122"/>
+                <a:cs typeface="Times New Roman" pitchFamily="34" charset="-120"/>
+              </a:rPr>
+              <a:t>A) The Two Letters</a:t>
+            </a:r>
+            <a:endParaRPr lang="en-US" sz="3200" dirty="0"/>
+          </a:p>
+        </p:txBody>
+      </p:sp>
+      <p:sp>
+        <p:nvSpPr>
+          <p:cNvPr id="6" name="Text 3"/>
+          <p:cNvSpPr/>
+          <p:nvPr/>
+        </p:nvSpPr>
+        <p:spPr>
+          <a:xfrm>
+            <a:off x="2697480" y="2240280"/>
+            <a:ext cx="9174175" cy="4206240"/>
           </a:xfrm>
           <a:prstGeom prst="rect">
             <a:avLst/>
@@ -17506,7 +17812,7 @@
               <a:buNone/>
             </a:pPr>
             <a:r>
-              <a:rPr lang="en-US" sz="4000" i="1" dirty="0">
+              <a:rPr lang="en-US" sz="3600" i="1" dirty="0">
                 <a:solidFill>
                   <a:srgbClr val="111111"/>
                 </a:solidFill>
@@ -17516,7 +17822,7 @@
               </a:rPr>
               <a:t>Air masses are classified with two letters as follows:</a:t>
             </a:r>
-            <a:endParaRPr lang="en-US" sz="4000" dirty="0"/>
+            <a:endParaRPr lang="en-US" sz="3600" dirty="0"/>
           </a:p>
           <a:p>
             <a:pPr algn="l" indent="0" marL="0">
@@ -17526,7 +17832,7 @@
               <a:buNone/>
             </a:pPr>
             <a:r>
-              <a:rPr lang="en-US" sz="4000" b="1" dirty="0">
+              <a:rPr lang="en-US" sz="3600" b="1" dirty="0">
                 <a:solidFill>
                   <a:srgbClr val="111111"/>
                 </a:solidFill>
@@ -17543,7 +17849,7 @@
               <a:buNone/>
             </a:pPr>
             <a:r>
-              <a:rPr lang="en-US" sz="4000" dirty="0">
+              <a:rPr lang="en-US" sz="3600" dirty="0">
                 <a:solidFill>
                   <a:srgbClr val="111111"/>
                 </a:solidFill>
@@ -17553,7 +17859,7 @@
               </a:rPr>
               <a:t>The letter c (continental) is used for an air mass formed over land, which is dry. The letter m (maritime) is used for an air mass formed over the sea, which is moist.</a:t>
             </a:r>
-            <a:endParaRPr lang="en-US" sz="4000" dirty="0"/>
+            <a:endParaRPr lang="en-US" sz="3600" dirty="0"/>
           </a:p>
         </p:txBody>
       </p:sp>
@@ -17718,8 +18024,49 @@
         </p:nvSpPr>
         <p:spPr>
           <a:xfrm>
-            <a:off x="365760" y="1783080"/>
-            <a:ext cx="6035040" cy="4617720"/>
+            <a:off x="365760" y="1737360"/>
+            <a:ext cx="6035040" cy="457200"/>
+          </a:xfrm>
+          <a:prstGeom prst="rect">
+            <a:avLst/>
+          </a:prstGeom>
+          <a:noFill/>
+          <a:ln/>
+        </p:spPr>
+        <p:txBody>
+          <a:bodyPr wrap="square" lIns="0" tIns="0" rIns="0" bIns="0" rtlCol="0" anchor="ctr">
+            <a:normAutofit/>
+          </a:bodyPr>
+          <a:lstStyle/>
+          <a:p>
+            <a:pPr algn="l" indent="0" marL="0">
+              <a:buNone/>
+            </a:pPr>
+            <a:r>
+              <a:rPr lang="en-US" sz="3000" b="1" dirty="0">
+                <a:solidFill>
+                  <a:srgbClr val="990011"/>
+                </a:solidFill>
+                <a:latin typeface="Times New Roman" pitchFamily="34" charset="0"/>
+                <a:ea typeface="Times New Roman" pitchFamily="34" charset="-122"/>
+                <a:cs typeface="Times New Roman" pitchFamily="34" charset="-120"/>
+              </a:rPr>
+              <a:t>A) The Two Letters</a:t>
+            </a:r>
+            <a:endParaRPr lang="en-US" sz="3000" dirty="0"/>
+          </a:p>
+        </p:txBody>
+      </p:sp>
+      <p:sp>
+        <p:nvSpPr>
+          <p:cNvPr id="5" name="Text 3"/>
+          <p:cNvSpPr/>
+          <p:nvPr/>
+        </p:nvSpPr>
+        <p:spPr>
+          <a:xfrm>
+            <a:off x="365760" y="2240280"/>
+            <a:ext cx="6035040" cy="4160520"/>
           </a:xfrm>
           <a:prstGeom prst="rect">
             <a:avLst/>
@@ -17771,7 +18118,7 @@
       </p:sp>
       <p:pic>
         <p:nvPicPr>
-          <p:cNvPr id="5" name="Image 0" descr="/home/claude/f4/img/v2/airmass_classes_big.png">    </p:cNvPr>
+          <p:cNvPr id="6" name="Image 0" descr="/home/claude/f4/img/v2/airmass_classes_big.png">    </p:cNvPr>
           <p:cNvPicPr>
             <a:picLocks noChangeAspect="1"/>
           </p:cNvPicPr>
@@ -17795,7 +18142,7 @@
       </p:pic>
       <p:sp>
         <p:nvSpPr>
-          <p:cNvPr id="6" name="Text 3"/>
+          <p:cNvPr id="7" name="Text 4"/>
           <p:cNvSpPr/>
           <p:nvPr/>
         </p:nvSpPr>
@@ -17961,7 +18308,7 @@
         <p:spPr>
           <a:xfrm>
             <a:off x="0" y="658368"/>
-            <a:ext cx="2468880" cy="5833872"/>
+            <a:ext cx="3840480" cy="5833872"/>
           </a:xfrm>
           <a:prstGeom prst="rect">
             <a:avLst/>
@@ -17976,8 +18323,8 @@
         </p:nvSpPr>
         <p:spPr>
           <a:xfrm>
-            <a:off x="2697480" y="1005840"/>
-            <a:ext cx="9174175" cy="731520"/>
+            <a:off x="4069080" y="1005840"/>
+            <a:ext cx="7802575" cy="731520"/>
           </a:xfrm>
           <a:prstGeom prst="rect">
             <a:avLst/>
@@ -18017,8 +18364,47 @@
         </p:nvSpPr>
         <p:spPr>
           <a:xfrm>
-            <a:off x="2697480" y="1783080"/>
-            <a:ext cx="9174175" cy="4663440"/>
+            <a:off x="4069080" y="1737360"/>
+            <a:ext cx="7802575" cy="457200"/>
+          </a:xfrm>
+          <a:prstGeom prst="rect">
+            <a:avLst/>
+          </a:prstGeom>
+          <a:noFill/>
+          <a:ln/>
+        </p:spPr>
+        <p:txBody>
+          <a:bodyPr wrap="square" lIns="0" tIns="0" rIns="0" bIns="0" rtlCol="0" anchor="ctr"/>
+          <a:lstStyle/>
+          <a:p>
+            <a:pPr algn="l" indent="0" marL="0">
+              <a:buNone/>
+            </a:pPr>
+            <a:r>
+              <a:rPr lang="en-US" sz="3200" b="1" dirty="0">
+                <a:solidFill>
+                  <a:srgbClr val="990011"/>
+                </a:solidFill>
+                <a:latin typeface="Times New Roman" pitchFamily="34" charset="0"/>
+                <a:ea typeface="Times New Roman" pitchFamily="34" charset="-122"/>
+                <a:cs typeface="Times New Roman" pitchFamily="34" charset="-120"/>
+              </a:rPr>
+              <a:t>B) Examples</a:t>
+            </a:r>
+            <a:endParaRPr lang="en-US" sz="3200" dirty="0"/>
+          </a:p>
+        </p:txBody>
+      </p:sp>
+      <p:sp>
+        <p:nvSpPr>
+          <p:cNvPr id="6" name="Text 3"/>
+          <p:cNvSpPr/>
+          <p:nvPr/>
+        </p:nvSpPr>
+        <p:spPr>
+          <a:xfrm>
+            <a:off x="4069080" y="2240280"/>
+            <a:ext cx="7802575" cy="4206240"/>
           </a:xfrm>
           <a:prstGeom prst="rect">
             <a:avLst/>
@@ -18037,7 +18423,7 @@
               <a:buNone/>
             </a:pPr>
             <a:r>
-              <a:rPr lang="en-US" sz="4000" b="1" dirty="0">
+              <a:rPr lang="en-US" sz="4000" i="1" dirty="0">
                 <a:solidFill>
                   <a:srgbClr val="111111"/>
                 </a:solidFill>
@@ -18045,8 +18431,11 @@
                 <a:ea typeface="Times New Roman" pitchFamily="34" charset="-122"/>
                 <a:cs typeface="Times New Roman" pitchFamily="34" charset="-120"/>
               </a:rPr>
-              <a:t>Examples: </a:t>
-            </a:r>
+              <a:t>The main air masses are the following:</a:t>
+            </a:r>
+            <a:endParaRPr lang="en-US" sz="4000" dirty="0"/>
+          </a:p>
+          <a:p>
             <a:pPr algn="l" indent="0" marL="0">
               <a:spcAft>
                 <a:spcPts val="800"/>
@@ -18054,7 +18443,7 @@
               <a:buNone/>
             </a:pPr>
             <a:r>
-              <a:rPr lang="en-US" sz="4000" dirty="0">
+              <a:rPr lang="en-US" sz="4000" b="1" dirty="0">
                 <a:solidFill>
                   <a:srgbClr val="111111"/>
                 </a:solidFill>
@@ -18062,7 +18451,24 @@
                 <a:ea typeface="Times New Roman" pitchFamily="34" charset="-122"/>
                 <a:cs typeface="Times New Roman" pitchFamily="34" charset="-120"/>
               </a:rPr>
-              <a:t>cT is hot and dry, like the Saharan air; mT is warm and moist, like the air over the tropical oceans. cP is cold and dry, like the Siberian air in winter, and mP is cool and moist, like the air of the North Atlantic.</a:t>
+              <a:t>Tropical continental (cT): </a:t>
+            </a:r>
+            <a:pPr algn="l" indent="0" marL="0">
+              <a:spcAft>
+                <a:spcPts val="800"/>
+              </a:spcAft>
+              <a:buNone/>
+            </a:pPr>
+            <a:r>
+              <a:rPr lang="en-US" sz="4000" dirty="0">
+                <a:solidFill>
+                  <a:srgbClr val="111111"/>
+                </a:solidFill>
+                <a:latin typeface="Times New Roman" pitchFamily="34" charset="0"/>
+                <a:ea typeface="Times New Roman" pitchFamily="34" charset="-122"/>
+                <a:cs typeface="Times New Roman" pitchFamily="34" charset="-120"/>
+              </a:rPr>
+              <a:t>It is hot and dry, like the air of the Sahara. It brings dry, sunny and dusty weather.</a:t>
             </a:r>
             <a:endParaRPr lang="en-US" sz="4000" dirty="0"/>
           </a:p>
@@ -18197,7 +18603,7 @@
         <p:spPr>
           <a:xfrm>
             <a:off x="0" y="658368"/>
-            <a:ext cx="2468880" cy="5833872"/>
+            <a:ext cx="5120640" cy="5833872"/>
           </a:xfrm>
           <a:prstGeom prst="rect">
             <a:avLst/>
@@ -18212,8 +18618,8 @@
         </p:nvSpPr>
         <p:spPr>
           <a:xfrm>
-            <a:off x="2697480" y="1005840"/>
-            <a:ext cx="9174175" cy="731520"/>
+            <a:off x="5349240" y="1005840"/>
+            <a:ext cx="6522415" cy="731520"/>
           </a:xfrm>
           <a:prstGeom prst="rect">
             <a:avLst/>
@@ -18239,7 +18645,7 @@
                 <a:ea typeface="Times New Roman" pitchFamily="34" charset="-122"/>
                 <a:cs typeface="Times New Roman" pitchFamily="34" charset="-120"/>
               </a:rPr>
-              <a:t>4. Types and Movements of Air Masses</a:t>
+              <a:t>3. Classification and Examples</a:t>
             </a:r>
             <a:endParaRPr lang="en-US" sz="3600" dirty="0"/>
           </a:p>
@@ -18253,8 +18659,47 @@
         </p:nvSpPr>
         <p:spPr>
           <a:xfrm>
-            <a:off x="2697480" y="1783080"/>
-            <a:ext cx="9174175" cy="4663440"/>
+            <a:off x="5349240" y="1737360"/>
+            <a:ext cx="6522415" cy="457200"/>
+          </a:xfrm>
+          <a:prstGeom prst="rect">
+            <a:avLst/>
+          </a:prstGeom>
+          <a:noFill/>
+          <a:ln/>
+        </p:spPr>
+        <p:txBody>
+          <a:bodyPr wrap="square" lIns="0" tIns="0" rIns="0" bIns="0" rtlCol="0" anchor="ctr"/>
+          <a:lstStyle/>
+          <a:p>
+            <a:pPr algn="l" indent="0" marL="0">
+              <a:buNone/>
+            </a:pPr>
+            <a:r>
+              <a:rPr lang="en-US" sz="3200" b="1" dirty="0">
+                <a:solidFill>
+                  <a:srgbClr val="990011"/>
+                </a:solidFill>
+                <a:latin typeface="Times New Roman" pitchFamily="34" charset="0"/>
+                <a:ea typeface="Times New Roman" pitchFamily="34" charset="-122"/>
+                <a:cs typeface="Times New Roman" pitchFamily="34" charset="-120"/>
+              </a:rPr>
+              <a:t>B) Examples</a:t>
+            </a:r>
+            <a:endParaRPr lang="en-US" sz="3200" dirty="0"/>
+          </a:p>
+        </p:txBody>
+      </p:sp>
+      <p:sp>
+        <p:nvSpPr>
+          <p:cNvPr id="6" name="Text 3"/>
+          <p:cNvSpPr/>
+          <p:nvPr/>
+        </p:nvSpPr>
+        <p:spPr>
+          <a:xfrm>
+            <a:off x="5349240" y="2240280"/>
+            <a:ext cx="6522415" cy="4206240"/>
           </a:xfrm>
           <a:prstGeom prst="rect">
             <a:avLst/>
@@ -18273,7 +18718,7 @@
               <a:buNone/>
             </a:pPr>
             <a:r>
-              <a:rPr lang="en-US" sz="4000" i="1" dirty="0">
+              <a:rPr lang="en-US" sz="4000" b="1" dirty="0">
                 <a:solidFill>
                   <a:srgbClr val="111111"/>
                 </a:solidFill>
@@ -18281,11 +18726,8 @@
                 <a:ea typeface="Times New Roman" pitchFamily="34" charset="-122"/>
                 <a:cs typeface="Times New Roman" pitchFamily="34" charset="-120"/>
               </a:rPr>
-              <a:t>Air masses are of the following types and move as follows:</a:t>
-            </a:r>
-            <a:endParaRPr lang="en-US" sz="4000" dirty="0"/>
-          </a:p>
-          <a:p>
+              <a:t>Tropical maritime (mT): </a:t>
+            </a:r>
             <a:pPr algn="l" indent="0" marL="0">
               <a:spcAft>
                 <a:spcPts val="800"/>
@@ -18293,7 +18735,7 @@
               <a:buNone/>
             </a:pPr>
             <a:r>
-              <a:rPr lang="en-US" sz="4000" b="1" dirty="0">
+              <a:rPr lang="en-US" sz="4000" dirty="0">
                 <a:solidFill>
                   <a:srgbClr val="111111"/>
                 </a:solidFill>
@@ -18301,24 +18743,7 @@
                 <a:ea typeface="Times New Roman" pitchFamily="34" charset="-122"/>
                 <a:cs typeface="Times New Roman" pitchFamily="34" charset="-120"/>
               </a:rPr>
-              <a:t>Warm air masses: </a:t>
-            </a:r>
-            <a:pPr algn="l" indent="0" marL="0">
-              <a:spcAft>
-                <a:spcPts val="800"/>
-              </a:spcAft>
-              <a:buNone/>
-            </a:pPr>
-            <a:r>
-              <a:rPr lang="en-US" sz="4000" dirty="0">
-                <a:solidFill>
-                  <a:srgbClr val="111111"/>
-                </a:solidFill>
-                <a:latin typeface="Times New Roman" pitchFamily="34" charset="0"/>
-                <a:ea typeface="Times New Roman" pitchFamily="34" charset="-122"/>
-                <a:cs typeface="Times New Roman" pitchFamily="34" charset="-120"/>
-              </a:rPr>
-              <a:t>A warm air mass is warmer than the surface it moves over, so it is cooled from below. It becomes stable and brings layer clouds, drizzle and fog.</a:t>
+              <a:t>It is warm and moist, like the air over the tropical oceans. It brings clouds and rain.</a:t>
             </a:r>
             <a:endParaRPr lang="en-US" sz="4000" dirty="0"/>
           </a:p>
@@ -18495,7 +18920,7 @@
                 <a:ea typeface="Times New Roman" pitchFamily="34" charset="-122"/>
                 <a:cs typeface="Times New Roman" pitchFamily="34" charset="-120"/>
               </a:rPr>
-              <a:t>4. Types and Movements of Air Masses</a:t>
+              <a:t>3. Classification and Examples</a:t>
             </a:r>
             <a:endParaRPr lang="en-US" sz="3600" dirty="0"/>
           </a:p>
@@ -18509,8 +18934,47 @@
         </p:nvSpPr>
         <p:spPr>
           <a:xfrm>
-            <a:off x="5349240" y="1783080"/>
-            <a:ext cx="6522415" cy="4663440"/>
+            <a:off x="5349240" y="1737360"/>
+            <a:ext cx="6522415" cy="457200"/>
+          </a:xfrm>
+          <a:prstGeom prst="rect">
+            <a:avLst/>
+          </a:prstGeom>
+          <a:noFill/>
+          <a:ln/>
+        </p:spPr>
+        <p:txBody>
+          <a:bodyPr wrap="square" lIns="0" tIns="0" rIns="0" bIns="0" rtlCol="0" anchor="ctr"/>
+          <a:lstStyle/>
+          <a:p>
+            <a:pPr algn="l" indent="0" marL="0">
+              <a:buNone/>
+            </a:pPr>
+            <a:r>
+              <a:rPr lang="en-US" sz="3200" b="1" dirty="0">
+                <a:solidFill>
+                  <a:srgbClr val="990011"/>
+                </a:solidFill>
+                <a:latin typeface="Times New Roman" pitchFamily="34" charset="0"/>
+                <a:ea typeface="Times New Roman" pitchFamily="34" charset="-122"/>
+                <a:cs typeface="Times New Roman" pitchFamily="34" charset="-120"/>
+              </a:rPr>
+              <a:t>B) Examples</a:t>
+            </a:r>
+            <a:endParaRPr lang="en-US" sz="3200" dirty="0"/>
+          </a:p>
+        </p:txBody>
+      </p:sp>
+      <p:sp>
+        <p:nvSpPr>
+          <p:cNvPr id="6" name="Text 3"/>
+          <p:cNvSpPr/>
+          <p:nvPr/>
+        </p:nvSpPr>
+        <p:spPr>
+          <a:xfrm>
+            <a:off x="5349240" y="2240280"/>
+            <a:ext cx="6522415" cy="4206240"/>
           </a:xfrm>
           <a:prstGeom prst="rect">
             <a:avLst/>
@@ -18537,7 +19001,7 @@
                 <a:ea typeface="Times New Roman" pitchFamily="34" charset="-122"/>
                 <a:cs typeface="Times New Roman" pitchFamily="34" charset="-120"/>
               </a:rPr>
-              <a:t>Cold air masses: </a:t>
+              <a:t>Polar continental (cP): </a:t>
             </a:r>
             <a:pPr algn="l" indent="0" marL="0">
               <a:spcAft>
@@ -18554,7 +19018,7 @@
                 <a:ea typeface="Times New Roman" pitchFamily="34" charset="-122"/>
                 <a:cs typeface="Times New Roman" pitchFamily="34" charset="-120"/>
               </a:rPr>
-              <a:t>A cold air mass is colder than the surface it moves over, so it is heated from below. It becomes unstable and brings cumulus clouds and showers.</a:t>
+              <a:t>It is cold and dry, like the air of Siberia in winter. It brings very cold, clear weather.</a:t>
             </a:r>
             <a:endParaRPr lang="en-US" sz="4000" dirty="0"/>
           </a:p>
@@ -18908,7 +19372,7 @@
         <p:spPr>
           <a:xfrm>
             <a:off x="0" y="658368"/>
-            <a:ext cx="3840480" cy="5833872"/>
+            <a:ext cx="5120640" cy="5833872"/>
           </a:xfrm>
           <a:prstGeom prst="rect">
             <a:avLst/>
@@ -18923,8 +19387,8 @@
         </p:nvSpPr>
         <p:spPr>
           <a:xfrm>
-            <a:off x="4069080" y="1005840"/>
-            <a:ext cx="7802575" cy="731520"/>
+            <a:off x="5349240" y="1005840"/>
+            <a:ext cx="6522415" cy="731520"/>
           </a:xfrm>
           <a:prstGeom prst="rect">
             <a:avLst/>
@@ -18950,7 +19414,7 @@
                 <a:ea typeface="Times New Roman" pitchFamily="34" charset="-122"/>
                 <a:cs typeface="Times New Roman" pitchFamily="34" charset="-120"/>
               </a:rPr>
-              <a:t>4. Types and Movements of Air Masses</a:t>
+              <a:t>3. Classification and Examples</a:t>
             </a:r>
             <a:endParaRPr lang="en-US" sz="3600" dirty="0"/>
           </a:p>
@@ -18964,8 +19428,47 @@
         </p:nvSpPr>
         <p:spPr>
           <a:xfrm>
-            <a:off x="4069080" y="1783080"/>
-            <a:ext cx="7802575" cy="4663440"/>
+            <a:off x="5349240" y="1737360"/>
+            <a:ext cx="6522415" cy="457200"/>
+          </a:xfrm>
+          <a:prstGeom prst="rect">
+            <a:avLst/>
+          </a:prstGeom>
+          <a:noFill/>
+          <a:ln/>
+        </p:spPr>
+        <p:txBody>
+          <a:bodyPr wrap="square" lIns="0" tIns="0" rIns="0" bIns="0" rtlCol="0" anchor="ctr"/>
+          <a:lstStyle/>
+          <a:p>
+            <a:pPr algn="l" indent="0" marL="0">
+              <a:buNone/>
+            </a:pPr>
+            <a:r>
+              <a:rPr lang="en-US" sz="3200" b="1" dirty="0">
+                <a:solidFill>
+                  <a:srgbClr val="990011"/>
+                </a:solidFill>
+                <a:latin typeface="Times New Roman" pitchFamily="34" charset="0"/>
+                <a:ea typeface="Times New Roman" pitchFamily="34" charset="-122"/>
+                <a:cs typeface="Times New Roman" pitchFamily="34" charset="-120"/>
+              </a:rPr>
+              <a:t>B) Examples</a:t>
+            </a:r>
+            <a:endParaRPr lang="en-US" sz="3200" dirty="0"/>
+          </a:p>
+        </p:txBody>
+      </p:sp>
+      <p:sp>
+        <p:nvSpPr>
+          <p:cNvPr id="6" name="Text 3"/>
+          <p:cNvSpPr/>
+          <p:nvPr/>
+        </p:nvSpPr>
+        <p:spPr>
+          <a:xfrm>
+            <a:off x="5349240" y="2240280"/>
+            <a:ext cx="6522415" cy="4206240"/>
           </a:xfrm>
           <a:prstGeom prst="rect">
             <a:avLst/>
@@ -18992,7 +19495,7 @@
                 <a:ea typeface="Times New Roman" pitchFamily="34" charset="-122"/>
                 <a:cs typeface="Times New Roman" pitchFamily="34" charset="-120"/>
               </a:rPr>
-              <a:t>Seasonal movement: </a:t>
+              <a:t>Polar maritime (mP): </a:t>
             </a:r>
             <a:pPr algn="l" indent="0" marL="0">
               <a:spcAft>
@@ -19009,7 +19512,7 @@
                 <a:ea typeface="Times New Roman" pitchFamily="34" charset="-122"/>
                 <a:cs typeface="Times New Roman" pitchFamily="34" charset="-120"/>
               </a:rPr>
-              <a:t>Air masses move with the pressure belts, which follow the overhead sun north and south during the year. As a result, each region is dominated by different air masses in different seasons.</a:t>
+              <a:t>It is cool and moist, like the air of the North Atlantic. It brings cool, showery weather.</a:t>
             </a:r>
             <a:endParaRPr lang="en-US" sz="4000" dirty="0"/>
           </a:p>
@@ -19127,129 +19630,9 @@
           </a:p>
         </p:txBody>
       </p:sp>
-      <p:sp>
-        <p:nvSpPr>
-          <p:cNvPr id="3" name="Text 1"/>
-          <p:cNvSpPr/>
-          <p:nvPr/>
-        </p:nvSpPr>
-        <p:spPr>
-          <a:xfrm>
-            <a:off x="365760" y="1005840"/>
-            <a:ext cx="11460175" cy="731520"/>
-          </a:xfrm>
-          <a:prstGeom prst="rect">
-            <a:avLst/>
-          </a:prstGeom>
-          <a:noFill/>
-          <a:ln/>
-        </p:spPr>
-        <p:txBody>
-          <a:bodyPr wrap="square" lIns="0" tIns="0" rIns="0" bIns="0" rtlCol="0" anchor="ctr">
-            <a:normAutofit/>
-          </a:bodyPr>
-          <a:lstStyle/>
-          <a:p>
-            <a:pPr algn="ctr" indent="0" marL="0">
-              <a:buNone/>
-            </a:pPr>
-            <a:r>
-              <a:rPr lang="en-US" sz="3600" b="1" dirty="0">
-                <a:solidFill>
-                  <a:srgbClr val="990011"/>
-                </a:solidFill>
-                <a:latin typeface="Times New Roman" pitchFamily="34" charset="0"/>
-                <a:ea typeface="Times New Roman" pitchFamily="34" charset="-122"/>
-                <a:cs typeface="Times New Roman" pitchFamily="34" charset="-120"/>
-              </a:rPr>
-              <a:t>5. Air Masses Affecting Cameroon and West Africa</a:t>
-            </a:r>
-            <a:endParaRPr lang="en-US" sz="3600" dirty="0"/>
-          </a:p>
-        </p:txBody>
-      </p:sp>
-      <p:sp>
-        <p:nvSpPr>
-          <p:cNvPr id="4" name="Text 2"/>
-          <p:cNvSpPr/>
-          <p:nvPr/>
-        </p:nvSpPr>
-        <p:spPr>
-          <a:xfrm>
-            <a:off x="365760" y="1783080"/>
-            <a:ext cx="6035040" cy="4617720"/>
-          </a:xfrm>
-          <a:prstGeom prst="rect">
-            <a:avLst/>
-          </a:prstGeom>
-          <a:noFill/>
-          <a:ln/>
-        </p:spPr>
-        <p:txBody>
-          <a:bodyPr wrap="square" lIns="0" tIns="0" rIns="0" bIns="0" rtlCol="0" anchor="t"/>
-          <a:lstStyle/>
-          <a:p>
-            <a:pPr algn="l" indent="0" marL="0">
-              <a:spcAft>
-                <a:spcPts val="800"/>
-              </a:spcAft>
-              <a:buNone/>
-            </a:pPr>
-            <a:r>
-              <a:rPr lang="en-US" sz="2800" i="1" dirty="0">
-                <a:solidFill>
-                  <a:srgbClr val="111111"/>
-                </a:solidFill>
-                <a:latin typeface="Times New Roman" pitchFamily="34" charset="0"/>
-                <a:ea typeface="Times New Roman" pitchFamily="34" charset="-122"/>
-                <a:cs typeface="Times New Roman" pitchFamily="34" charset="-120"/>
-              </a:rPr>
-              <a:t>Two air masses control the seasons of Cameroon as follows:</a:t>
-            </a:r>
-            <a:endParaRPr lang="en-US" sz="2800" dirty="0"/>
-          </a:p>
-          <a:p>
-            <a:pPr algn="l" indent="0" marL="0">
-              <a:spcAft>
-                <a:spcPts val="800"/>
-              </a:spcAft>
-              <a:buNone/>
-            </a:pPr>
-            <a:r>
-              <a:rPr lang="en-US" sz="2800" b="1" dirty="0">
-                <a:solidFill>
-                  <a:srgbClr val="111111"/>
-                </a:solidFill>
-                <a:latin typeface="Times New Roman" pitchFamily="34" charset="0"/>
-                <a:ea typeface="Times New Roman" pitchFamily="34" charset="-122"/>
-                <a:cs typeface="Times New Roman" pitchFamily="34" charset="-120"/>
-              </a:rPr>
-              <a:t>Tropical continental air (cT): </a:t>
-            </a:r>
-            <a:pPr algn="l" indent="0" marL="0">
-              <a:spcAft>
-                <a:spcPts val="800"/>
-              </a:spcAft>
-              <a:buNone/>
-            </a:pPr>
-            <a:r>
-              <a:rPr lang="en-US" sz="2800" dirty="0">
-                <a:solidFill>
-                  <a:srgbClr val="111111"/>
-                </a:solidFill>
-                <a:latin typeface="Times New Roman" pitchFamily="34" charset="0"/>
-                <a:ea typeface="Times New Roman" pitchFamily="34" charset="-122"/>
-                <a:cs typeface="Times New Roman" pitchFamily="34" charset="-120"/>
-              </a:rPr>
-              <a:t>It forms over the Sahara and is hot by day, very dry, dusty and stable, blowing as the north-east Harmattan. It dominates the dry season in Garoua from about November to March, with sunshine, haze and low humidity.</a:t>
-            </a:r>
-            <a:endParaRPr lang="en-US" sz="2800" dirty="0"/>
-          </a:p>
-        </p:txBody>
-      </p:sp>
       <p:pic>
         <p:nvPicPr>
-          <p:cNvPr id="5" name="Image 0" descr="/home/claude/f4/img/v2/f2t_harmattan.jpg">    </p:cNvPr>
+          <p:cNvPr id="3" name="Image 0" descr="/home/claude/f4/img/minesec_sheet.png">    </p:cNvPr>
           <p:cNvPicPr>
             <a:picLocks noChangeAspect="1"/>
           </p:cNvPicPr>
@@ -19263,8 +19646,8 @@
         </p:blipFill>
         <p:spPr>
           <a:xfrm>
-            <a:off x="6537960" y="2400897"/>
-            <a:ext cx="5470855" cy="3034615"/>
+            <a:off x="0" y="658368"/>
+            <a:ext cx="2468880" cy="5833872"/>
           </a:xfrm>
           <a:prstGeom prst="rect">
             <a:avLst/>
@@ -19273,14 +19656,14 @@
       </p:pic>
       <p:sp>
         <p:nvSpPr>
-          <p:cNvPr id="6" name="Text 3"/>
+          <p:cNvPr id="4" name="Text 1"/>
           <p:cNvSpPr/>
           <p:nvPr/>
         </p:nvSpPr>
         <p:spPr>
           <a:xfrm>
-            <a:off x="6537960" y="6089904"/>
-            <a:ext cx="5470855" cy="347472"/>
+            <a:off x="2697480" y="1005840"/>
+            <a:ext cx="9174175" cy="731520"/>
           </a:xfrm>
           <a:prstGeom prst="rect">
             <a:avLst/>
@@ -19289,24 +19672,105 @@
           <a:ln/>
         </p:spPr>
         <p:txBody>
-          <a:bodyPr wrap="square" lIns="0" tIns="0" rIns="0" bIns="0" rtlCol="0" anchor="ctr"/>
+          <a:bodyPr wrap="square" lIns="0" tIns="0" rIns="0" bIns="0" rtlCol="0" anchor="ctr">
+            <a:normAutofit/>
+          </a:bodyPr>
           <a:lstStyle/>
           <a:p>
             <a:pPr algn="ctr" indent="0" marL="0">
               <a:buNone/>
             </a:pPr>
             <a:r>
-              <a:rPr lang="en-US" sz="1600" i="1" dirty="0">
-                <a:solidFill>
-                  <a:srgbClr val="555555"/>
+              <a:rPr lang="en-US" sz="3600" b="1" dirty="0">
+                <a:solidFill>
+                  <a:srgbClr val="990011"/>
                 </a:solidFill>
                 <a:latin typeface="Times New Roman" pitchFamily="34" charset="0"/>
                 <a:ea typeface="Times New Roman" pitchFamily="34" charset="-122"/>
                 <a:cs typeface="Times New Roman" pitchFamily="34" charset="-120"/>
               </a:rPr>
-              <a:t>Illustration: the Harmattan</a:t>
-            </a:r>
-            <a:endParaRPr lang="en-US" sz="1600" dirty="0"/>
+              <a:t>4. Types and Movements of Air Masses</a:t>
+            </a:r>
+            <a:endParaRPr lang="en-US" sz="3600" dirty="0"/>
+          </a:p>
+        </p:txBody>
+      </p:sp>
+      <p:sp>
+        <p:nvSpPr>
+          <p:cNvPr id="5" name="Text 2"/>
+          <p:cNvSpPr/>
+          <p:nvPr/>
+        </p:nvSpPr>
+        <p:spPr>
+          <a:xfrm>
+            <a:off x="2697480" y="1783080"/>
+            <a:ext cx="9174175" cy="4663440"/>
+          </a:xfrm>
+          <a:prstGeom prst="rect">
+            <a:avLst/>
+          </a:prstGeom>
+          <a:noFill/>
+          <a:ln/>
+        </p:spPr>
+        <p:txBody>
+          <a:bodyPr wrap="square" lIns="0" tIns="0" rIns="0" bIns="0" rtlCol="0" anchor="t"/>
+          <a:lstStyle/>
+          <a:p>
+            <a:pPr algn="l" indent="0" marL="0">
+              <a:spcAft>
+                <a:spcPts val="800"/>
+              </a:spcAft>
+              <a:buNone/>
+            </a:pPr>
+            <a:r>
+              <a:rPr lang="en-US" sz="4000" i="1" dirty="0">
+                <a:solidFill>
+                  <a:srgbClr val="111111"/>
+                </a:solidFill>
+                <a:latin typeface="Times New Roman" pitchFamily="34" charset="0"/>
+                <a:ea typeface="Times New Roman" pitchFamily="34" charset="-122"/>
+                <a:cs typeface="Times New Roman" pitchFamily="34" charset="-120"/>
+              </a:rPr>
+              <a:t>Air masses are of the following types and move as follows:</a:t>
+            </a:r>
+            <a:endParaRPr lang="en-US" sz="4000" dirty="0"/>
+          </a:p>
+          <a:p>
+            <a:pPr algn="l" indent="0" marL="0">
+              <a:spcAft>
+                <a:spcPts val="800"/>
+              </a:spcAft>
+              <a:buNone/>
+            </a:pPr>
+            <a:r>
+              <a:rPr lang="en-US" sz="4000" b="1" dirty="0">
+                <a:solidFill>
+                  <a:srgbClr val="111111"/>
+                </a:solidFill>
+                <a:latin typeface="Times New Roman" pitchFamily="34" charset="0"/>
+                <a:ea typeface="Times New Roman" pitchFamily="34" charset="-122"/>
+                <a:cs typeface="Times New Roman" pitchFamily="34" charset="-120"/>
+              </a:rPr>
+              <a:t>Warm air masses: </a:t>
+            </a:r>
+            <a:pPr algn="l" indent="0" marL="0">
+              <a:spcAft>
+                <a:spcPts val="800"/>
+              </a:spcAft>
+              <a:buNone/>
+            </a:pPr>
+            <a:r>
+              <a:rPr lang="en-US" sz="4000" dirty="0">
+                <a:solidFill>
+                  <a:srgbClr val="111111"/>
+                </a:solidFill>
+                <a:latin typeface="Times New Roman" pitchFamily="34" charset="0"/>
+                <a:ea typeface="Times New Roman" pitchFamily="34" charset="-122"/>
+                <a:cs typeface="Times New Roman" pitchFamily="34" charset="-120"/>
+              </a:rPr>
+              <a:t>A warm air mass is warmer than the surface it moves over, so it is cooled from below. It becomes stable and brings layer clouds, drizzle and fog.</a:t>
+            </a:r>
+            <a:endParaRPr lang="en-US" sz="4000" dirty="0"/>
           </a:p>
         </p:txBody>
       </p:sp>
@@ -19422,109 +19886,9 @@
           </a:p>
         </p:txBody>
       </p:sp>
-      <p:sp>
-        <p:nvSpPr>
-          <p:cNvPr id="3" name="Text 1"/>
-          <p:cNvSpPr/>
-          <p:nvPr/>
-        </p:nvSpPr>
-        <p:spPr>
-          <a:xfrm>
-            <a:off x="365760" y="1005840"/>
-            <a:ext cx="11460175" cy="731520"/>
-          </a:xfrm>
-          <a:prstGeom prst="rect">
-            <a:avLst/>
-          </a:prstGeom>
-          <a:noFill/>
-          <a:ln/>
-        </p:spPr>
-        <p:txBody>
-          <a:bodyPr wrap="square" lIns="0" tIns="0" rIns="0" bIns="0" rtlCol="0" anchor="ctr">
-            <a:normAutofit/>
-          </a:bodyPr>
-          <a:lstStyle/>
-          <a:p>
-            <a:pPr algn="ctr" indent="0" marL="0">
-              <a:buNone/>
-            </a:pPr>
-            <a:r>
-              <a:rPr lang="en-US" sz="3600" b="1" dirty="0">
-                <a:solidFill>
-                  <a:srgbClr val="990011"/>
-                </a:solidFill>
-                <a:latin typeface="Times New Roman" pitchFamily="34" charset="0"/>
-                <a:ea typeface="Times New Roman" pitchFamily="34" charset="-122"/>
-                <a:cs typeface="Times New Roman" pitchFamily="34" charset="-120"/>
-              </a:rPr>
-              <a:t>5. Air Masses Affecting Cameroon and West Africa</a:t>
-            </a:r>
-            <a:endParaRPr lang="en-US" sz="3600" dirty="0"/>
-          </a:p>
-        </p:txBody>
-      </p:sp>
-      <p:sp>
-        <p:nvSpPr>
-          <p:cNvPr id="4" name="Text 2"/>
-          <p:cNvSpPr/>
-          <p:nvPr/>
-        </p:nvSpPr>
-        <p:spPr>
-          <a:xfrm>
-            <a:off x="365760" y="1783080"/>
-            <a:ext cx="6035040" cy="4617720"/>
-          </a:xfrm>
-          <a:prstGeom prst="rect">
-            <a:avLst/>
-          </a:prstGeom>
-          <a:noFill/>
-          <a:ln/>
-        </p:spPr>
-        <p:txBody>
-          <a:bodyPr wrap="square" lIns="0" tIns="0" rIns="0" bIns="0" rtlCol="0" anchor="t"/>
-          <a:lstStyle/>
-          <a:p>
-            <a:pPr algn="l" indent="0" marL="0">
-              <a:spcAft>
-                <a:spcPts val="800"/>
-              </a:spcAft>
-              <a:buNone/>
-            </a:pPr>
-            <a:r>
-              <a:rPr lang="en-US" sz="3200" b="1" dirty="0">
-                <a:solidFill>
-                  <a:srgbClr val="111111"/>
-                </a:solidFill>
-                <a:latin typeface="Times New Roman" pitchFamily="34" charset="0"/>
-                <a:ea typeface="Times New Roman" pitchFamily="34" charset="-122"/>
-                <a:cs typeface="Times New Roman" pitchFamily="34" charset="-120"/>
-              </a:rPr>
-              <a:t>Tropical maritime air (mT): </a:t>
-            </a:r>
-            <a:pPr algn="l" indent="0" marL="0">
-              <a:spcAft>
-                <a:spcPts val="800"/>
-              </a:spcAft>
-              <a:buNone/>
-            </a:pPr>
-            <a:r>
-              <a:rPr lang="en-US" sz="3200" dirty="0">
-                <a:solidFill>
-                  <a:srgbClr val="111111"/>
-                </a:solidFill>
-                <a:latin typeface="Times New Roman" pitchFamily="34" charset="0"/>
-                <a:ea typeface="Times New Roman" pitchFamily="34" charset="-122"/>
-                <a:cs typeface="Times New Roman" pitchFamily="34" charset="-120"/>
-              </a:rPr>
-              <a:t>It forms over the South Atlantic Ocean around Saint Helena and is warm, very moist and unstable, blowing as the south-west monsoon. It brings the rainy season to Garoua from about May to October, with cumulonimbus clouds and storms.</a:t>
-            </a:r>
-            <a:endParaRPr lang="en-US" sz="3200" dirty="0"/>
-          </a:p>
-        </p:txBody>
-      </p:sp>
       <p:pic>
         <p:nvPicPr>
-          <p:cNvPr id="5" name="Image 0" descr="/home/claude/f4/img/v2/f4_heavyrain.jpg">    </p:cNvPr>
+          <p:cNvPr id="3" name="Image 0" descr="/home/claude/f4/img/minesec_sheet.png">    </p:cNvPr>
           <p:cNvPicPr>
             <a:picLocks noChangeAspect="1"/>
           </p:cNvPicPr>
@@ -19538,8 +19902,8 @@
         </p:blipFill>
         <p:spPr>
           <a:xfrm>
-            <a:off x="6537960" y="2400897"/>
-            <a:ext cx="5470855" cy="3034615"/>
+            <a:off x="0" y="658368"/>
+            <a:ext cx="5120640" cy="5833872"/>
           </a:xfrm>
           <a:prstGeom prst="rect">
             <a:avLst/>
@@ -19548,14 +19912,14 @@
       </p:pic>
       <p:sp>
         <p:nvSpPr>
-          <p:cNvPr id="6" name="Text 3"/>
+          <p:cNvPr id="4" name="Text 1"/>
           <p:cNvSpPr/>
           <p:nvPr/>
         </p:nvSpPr>
         <p:spPr>
           <a:xfrm>
-            <a:off x="6537960" y="6089904"/>
-            <a:ext cx="5470855" cy="347472"/>
+            <a:off x="5349240" y="1005840"/>
+            <a:ext cx="6522415" cy="731520"/>
           </a:xfrm>
           <a:prstGeom prst="rect">
             <a:avLst/>
@@ -19564,24 +19928,85 @@
           <a:ln/>
         </p:spPr>
         <p:txBody>
-          <a:bodyPr wrap="square" lIns="0" tIns="0" rIns="0" bIns="0" rtlCol="0" anchor="ctr"/>
+          <a:bodyPr wrap="square" lIns="0" tIns="0" rIns="0" bIns="0" rtlCol="0" anchor="ctr">
+            <a:normAutofit/>
+          </a:bodyPr>
           <a:lstStyle/>
           <a:p>
             <a:pPr algn="ctr" indent="0" marL="0">
               <a:buNone/>
             </a:pPr>
             <a:r>
-              <a:rPr lang="en-US" sz="1600" i="1" dirty="0">
-                <a:solidFill>
-                  <a:srgbClr val="555555"/>
+              <a:rPr lang="en-US" sz="3600" b="1" dirty="0">
+                <a:solidFill>
+                  <a:srgbClr val="990011"/>
                 </a:solidFill>
                 <a:latin typeface="Times New Roman" pitchFamily="34" charset="0"/>
                 <a:ea typeface="Times New Roman" pitchFamily="34" charset="-122"/>
                 <a:cs typeface="Times New Roman" pitchFamily="34" charset="-120"/>
               </a:rPr>
-              <a:t>Illustration: heavy rain</a:t>
-            </a:r>
-            <a:endParaRPr lang="en-US" sz="1600" dirty="0"/>
+              <a:t>4. Types and Movements of Air Masses</a:t>
+            </a:r>
+            <a:endParaRPr lang="en-US" sz="3600" dirty="0"/>
+          </a:p>
+        </p:txBody>
+      </p:sp>
+      <p:sp>
+        <p:nvSpPr>
+          <p:cNvPr id="5" name="Text 2"/>
+          <p:cNvSpPr/>
+          <p:nvPr/>
+        </p:nvSpPr>
+        <p:spPr>
+          <a:xfrm>
+            <a:off x="5349240" y="1783080"/>
+            <a:ext cx="6522415" cy="4663440"/>
+          </a:xfrm>
+          <a:prstGeom prst="rect">
+            <a:avLst/>
+          </a:prstGeom>
+          <a:noFill/>
+          <a:ln/>
+        </p:spPr>
+        <p:txBody>
+          <a:bodyPr wrap="square" lIns="0" tIns="0" rIns="0" bIns="0" rtlCol="0" anchor="t"/>
+          <a:lstStyle/>
+          <a:p>
+            <a:pPr algn="l" indent="0" marL="0">
+              <a:spcAft>
+                <a:spcPts val="800"/>
+              </a:spcAft>
+              <a:buNone/>
+            </a:pPr>
+            <a:r>
+              <a:rPr lang="en-US" sz="4000" b="1" dirty="0">
+                <a:solidFill>
+                  <a:srgbClr val="111111"/>
+                </a:solidFill>
+                <a:latin typeface="Times New Roman" pitchFamily="34" charset="0"/>
+                <a:ea typeface="Times New Roman" pitchFamily="34" charset="-122"/>
+                <a:cs typeface="Times New Roman" pitchFamily="34" charset="-120"/>
+              </a:rPr>
+              <a:t>Cold air masses: </a:t>
+            </a:r>
+            <a:pPr algn="l" indent="0" marL="0">
+              <a:spcAft>
+                <a:spcPts val="800"/>
+              </a:spcAft>
+              <a:buNone/>
+            </a:pPr>
+            <a:r>
+              <a:rPr lang="en-US" sz="4000" dirty="0">
+                <a:solidFill>
+                  <a:srgbClr val="111111"/>
+                </a:solidFill>
+                <a:latin typeface="Times New Roman" pitchFamily="34" charset="0"/>
+                <a:ea typeface="Times New Roman" pitchFamily="34" charset="-122"/>
+                <a:cs typeface="Times New Roman" pitchFamily="34" charset="-120"/>
+              </a:rPr>
+              <a:t>A cold air mass is colder than the surface it moves over, so it is heated from below. It becomes unstable and brings cumulus clouds and showers.</a:t>
+            </a:r>
+            <a:endParaRPr lang="en-US" sz="4000" dirty="0"/>
           </a:p>
         </p:txBody>
       </p:sp>
@@ -19697,109 +20122,9 @@
           </a:p>
         </p:txBody>
       </p:sp>
-      <p:sp>
-        <p:nvSpPr>
-          <p:cNvPr id="3" name="Text 1"/>
-          <p:cNvSpPr/>
-          <p:nvPr/>
-        </p:nvSpPr>
-        <p:spPr>
-          <a:xfrm>
-            <a:off x="365760" y="1005840"/>
-            <a:ext cx="11460175" cy="731520"/>
-          </a:xfrm>
-          <a:prstGeom prst="rect">
-            <a:avLst/>
-          </a:prstGeom>
-          <a:noFill/>
-          <a:ln/>
-        </p:spPr>
-        <p:txBody>
-          <a:bodyPr wrap="square" lIns="0" tIns="0" rIns="0" bIns="0" rtlCol="0" anchor="ctr">
-            <a:normAutofit/>
-          </a:bodyPr>
-          <a:lstStyle/>
-          <a:p>
-            <a:pPr algn="ctr" indent="0" marL="0">
-              <a:buNone/>
-            </a:pPr>
-            <a:r>
-              <a:rPr lang="en-US" sz="3600" b="1" dirty="0">
-                <a:solidFill>
-                  <a:srgbClr val="990011"/>
-                </a:solidFill>
-                <a:latin typeface="Times New Roman" pitchFamily="34" charset="0"/>
-                <a:ea typeface="Times New Roman" pitchFamily="34" charset="-122"/>
-                <a:cs typeface="Times New Roman" pitchFamily="34" charset="-120"/>
-              </a:rPr>
-              <a:t>5. Air Masses Affecting Cameroon and West Africa</a:t>
-            </a:r>
-            <a:endParaRPr lang="en-US" sz="3600" dirty="0"/>
-          </a:p>
-        </p:txBody>
-      </p:sp>
-      <p:sp>
-        <p:nvSpPr>
-          <p:cNvPr id="4" name="Text 2"/>
-          <p:cNvSpPr/>
-          <p:nvPr/>
-        </p:nvSpPr>
-        <p:spPr>
-          <a:xfrm>
-            <a:off x="365760" y="1783080"/>
-            <a:ext cx="6035040" cy="4617720"/>
-          </a:xfrm>
-          <a:prstGeom prst="rect">
-            <a:avLst/>
-          </a:prstGeom>
-          <a:noFill/>
-          <a:ln/>
-        </p:spPr>
-        <p:txBody>
-          <a:bodyPr wrap="square" lIns="0" tIns="0" rIns="0" bIns="0" rtlCol="0" anchor="t"/>
-          <a:lstStyle/>
-          <a:p>
-            <a:pPr algn="l" indent="0" marL="0">
-              <a:spcAft>
-                <a:spcPts val="800"/>
-              </a:spcAft>
-              <a:buNone/>
-            </a:pPr>
-            <a:r>
-              <a:rPr lang="en-US" sz="3200" b="1" dirty="0">
-                <a:solidFill>
-                  <a:srgbClr val="111111"/>
-                </a:solidFill>
-                <a:latin typeface="Times New Roman" pitchFamily="34" charset="0"/>
-                <a:ea typeface="Times New Roman" pitchFamily="34" charset="-122"/>
-                <a:cs typeface="Times New Roman" pitchFamily="34" charset="-120"/>
-              </a:rPr>
-              <a:t>The Intertropical Front (ITF): </a:t>
-            </a:r>
-            <a:pPr algn="l" indent="0" marL="0">
-              <a:spcAft>
-                <a:spcPts val="800"/>
-              </a:spcAft>
-              <a:buNone/>
-            </a:pPr>
-            <a:r>
-              <a:rPr lang="en-US" sz="3200" dirty="0">
-                <a:solidFill>
-                  <a:srgbClr val="111111"/>
-                </a:solidFill>
-                <a:latin typeface="Times New Roman" pitchFamily="34" charset="0"/>
-                <a:ea typeface="Times New Roman" pitchFamily="34" charset="-122"/>
-                <a:cs typeface="Times New Roman" pitchFamily="34" charset="-120"/>
-              </a:rPr>
-              <a:t>The two air masses meet along the ITF, which moves north in the northern summer and south in winter. Places south of the ITF receive rain, which explains why the rainy season is longer in the south of Cameroon than in the north.</a:t>
-            </a:r>
-            <a:endParaRPr lang="en-US" sz="3200" dirty="0"/>
-          </a:p>
-        </p:txBody>
-      </p:sp>
       <p:pic>
         <p:nvPicPr>
-          <p:cNvPr id="5" name="Image 0" descr="/home/claude/f4/img/v2/wa_airmasses_big.png">    </p:cNvPr>
+          <p:cNvPr id="3" name="Image 0" descr="/home/claude/f4/img/minesec_sheet.png">    </p:cNvPr>
           <p:cNvPicPr>
             <a:picLocks noChangeAspect="1"/>
           </p:cNvPicPr>
@@ -19813,8 +20138,8 @@
         </p:blipFill>
         <p:spPr>
           <a:xfrm>
-            <a:off x="6537960" y="2550490"/>
-            <a:ext cx="5470855" cy="2735428"/>
+            <a:off x="0" y="658368"/>
+            <a:ext cx="3840480" cy="5833872"/>
           </a:xfrm>
           <a:prstGeom prst="rect">
             <a:avLst/>
@@ -19823,14 +20148,14 @@
       </p:pic>
       <p:sp>
         <p:nvSpPr>
-          <p:cNvPr id="6" name="Text 3"/>
+          <p:cNvPr id="4" name="Text 1"/>
           <p:cNvSpPr/>
           <p:nvPr/>
         </p:nvSpPr>
         <p:spPr>
           <a:xfrm>
-            <a:off x="6537960" y="6089904"/>
-            <a:ext cx="5470855" cy="347472"/>
+            <a:off x="4069080" y="1005840"/>
+            <a:ext cx="7802575" cy="731520"/>
           </a:xfrm>
           <a:prstGeom prst="rect">
             <a:avLst/>
@@ -19839,24 +20164,85 @@
           <a:ln/>
         </p:spPr>
         <p:txBody>
-          <a:bodyPr wrap="square" lIns="0" tIns="0" rIns="0" bIns="0" rtlCol="0" anchor="ctr"/>
+          <a:bodyPr wrap="square" lIns="0" tIns="0" rIns="0" bIns="0" rtlCol="0" anchor="ctr">
+            <a:normAutofit/>
+          </a:bodyPr>
           <a:lstStyle/>
           <a:p>
             <a:pPr algn="ctr" indent="0" marL="0">
               <a:buNone/>
             </a:pPr>
             <a:r>
-              <a:rPr lang="en-US" sz="1600" i="1" dirty="0">
-                <a:solidFill>
-                  <a:srgbClr val="555555"/>
+              <a:rPr lang="en-US" sz="3600" b="1" dirty="0">
+                <a:solidFill>
+                  <a:srgbClr val="990011"/>
                 </a:solidFill>
                 <a:latin typeface="Times New Roman" pitchFamily="34" charset="0"/>
                 <a:ea typeface="Times New Roman" pitchFamily="34" charset="-122"/>
                 <a:cs typeface="Times New Roman" pitchFamily="34" charset="-120"/>
               </a:rPr>
-              <a:t>Illustration: the air masses of West Africa</a:t>
-            </a:r>
-            <a:endParaRPr lang="en-US" sz="1600" dirty="0"/>
+              <a:t>4. Types and Movements of Air Masses</a:t>
+            </a:r>
+            <a:endParaRPr lang="en-US" sz="3600" dirty="0"/>
+          </a:p>
+        </p:txBody>
+      </p:sp>
+      <p:sp>
+        <p:nvSpPr>
+          <p:cNvPr id="5" name="Text 2"/>
+          <p:cNvSpPr/>
+          <p:nvPr/>
+        </p:nvSpPr>
+        <p:spPr>
+          <a:xfrm>
+            <a:off x="4069080" y="1783080"/>
+            <a:ext cx="7802575" cy="4663440"/>
+          </a:xfrm>
+          <a:prstGeom prst="rect">
+            <a:avLst/>
+          </a:prstGeom>
+          <a:noFill/>
+          <a:ln/>
+        </p:spPr>
+        <p:txBody>
+          <a:bodyPr wrap="square" lIns="0" tIns="0" rIns="0" bIns="0" rtlCol="0" anchor="t"/>
+          <a:lstStyle/>
+          <a:p>
+            <a:pPr algn="l" indent="0" marL="0">
+              <a:spcAft>
+                <a:spcPts val="800"/>
+              </a:spcAft>
+              <a:buNone/>
+            </a:pPr>
+            <a:r>
+              <a:rPr lang="en-US" sz="4000" b="1" dirty="0">
+                <a:solidFill>
+                  <a:srgbClr val="111111"/>
+                </a:solidFill>
+                <a:latin typeface="Times New Roman" pitchFamily="34" charset="0"/>
+                <a:ea typeface="Times New Roman" pitchFamily="34" charset="-122"/>
+                <a:cs typeface="Times New Roman" pitchFamily="34" charset="-120"/>
+              </a:rPr>
+              <a:t>Seasonal movement: </a:t>
+            </a:r>
+            <a:pPr algn="l" indent="0" marL="0">
+              <a:spcAft>
+                <a:spcPts val="800"/>
+              </a:spcAft>
+              <a:buNone/>
+            </a:pPr>
+            <a:r>
+              <a:rPr lang="en-US" sz="4000" dirty="0">
+                <a:solidFill>
+                  <a:srgbClr val="111111"/>
+                </a:solidFill>
+                <a:latin typeface="Times New Roman" pitchFamily="34" charset="0"/>
+                <a:ea typeface="Times New Roman" pitchFamily="34" charset="-122"/>
+                <a:cs typeface="Times New Roman" pitchFamily="34" charset="-120"/>
+              </a:rPr>
+              <a:t>Air masses move with the pressure belts, which follow the overhead sun north and south during the year. As a result, each region is dominated by different air masses in different seasons.</a:t>
+            </a:r>
+            <a:endParaRPr lang="en-US" sz="4000" dirty="0"/>
           </a:p>
         </p:txBody>
       </p:sp>
@@ -19966,15 +20352,135 @@
                 <a:ea typeface="Calibri" pitchFamily="34" charset="-122"/>
                 <a:cs typeface="Calibri" pitchFamily="34" charset="-120"/>
               </a:rPr>
-              <a:t>FORMATIVE EVALUATION</a:t>
+              <a:t>BOARD SUMMARY</a:t>
             </a:r>
             <a:endParaRPr lang="en-US" sz="1400" dirty="0"/>
+          </a:p>
+        </p:txBody>
+      </p:sp>
+      <p:sp>
+        <p:nvSpPr>
+          <p:cNvPr id="3" name="Text 1"/>
+          <p:cNvSpPr/>
+          <p:nvPr/>
+        </p:nvSpPr>
+        <p:spPr>
+          <a:xfrm>
+            <a:off x="365760" y="1005840"/>
+            <a:ext cx="11460175" cy="731520"/>
+          </a:xfrm>
+          <a:prstGeom prst="rect">
+            <a:avLst/>
+          </a:prstGeom>
+          <a:noFill/>
+          <a:ln/>
+        </p:spPr>
+        <p:txBody>
+          <a:bodyPr wrap="square" lIns="0" tIns="0" rIns="0" bIns="0" rtlCol="0" anchor="ctr">
+            <a:normAutofit/>
+          </a:bodyPr>
+          <a:lstStyle/>
+          <a:p>
+            <a:pPr algn="ctr" indent="0" marL="0">
+              <a:buNone/>
+            </a:pPr>
+            <a:r>
+              <a:rPr lang="en-US" sz="3600" b="1" dirty="0">
+                <a:solidFill>
+                  <a:srgbClr val="990011"/>
+                </a:solidFill>
+                <a:latin typeface="Times New Roman" pitchFamily="34" charset="0"/>
+                <a:ea typeface="Times New Roman" pitchFamily="34" charset="-122"/>
+                <a:cs typeface="Times New Roman" pitchFamily="34" charset="-120"/>
+              </a:rPr>
+              <a:t>5. Air Masses Affecting Cameroon and West Africa</a:t>
+            </a:r>
+            <a:endParaRPr lang="en-US" sz="3600" dirty="0"/>
+          </a:p>
+        </p:txBody>
+      </p:sp>
+      <p:sp>
+        <p:nvSpPr>
+          <p:cNvPr id="4" name="Text 2"/>
+          <p:cNvSpPr/>
+          <p:nvPr/>
+        </p:nvSpPr>
+        <p:spPr>
+          <a:xfrm>
+            <a:off x="365760" y="1783080"/>
+            <a:ext cx="6035040" cy="4617720"/>
+          </a:xfrm>
+          <a:prstGeom prst="rect">
+            <a:avLst/>
+          </a:prstGeom>
+          <a:noFill/>
+          <a:ln/>
+        </p:spPr>
+        <p:txBody>
+          <a:bodyPr wrap="square" lIns="0" tIns="0" rIns="0" bIns="0" rtlCol="0" anchor="t"/>
+          <a:lstStyle/>
+          <a:p>
+            <a:pPr algn="l" indent="0" marL="0">
+              <a:spcAft>
+                <a:spcPts val="800"/>
+              </a:spcAft>
+              <a:buNone/>
+            </a:pPr>
+            <a:r>
+              <a:rPr lang="en-US" sz="2800" i="1" dirty="0">
+                <a:solidFill>
+                  <a:srgbClr val="111111"/>
+                </a:solidFill>
+                <a:latin typeface="Times New Roman" pitchFamily="34" charset="0"/>
+                <a:ea typeface="Times New Roman" pitchFamily="34" charset="-122"/>
+                <a:cs typeface="Times New Roman" pitchFamily="34" charset="-120"/>
+              </a:rPr>
+              <a:t>Two air masses control the seasons of Cameroon as follows:</a:t>
+            </a:r>
+            <a:endParaRPr lang="en-US" sz="2800" dirty="0"/>
+          </a:p>
+          <a:p>
+            <a:pPr algn="l" indent="0" marL="0">
+              <a:spcAft>
+                <a:spcPts val="800"/>
+              </a:spcAft>
+              <a:buNone/>
+            </a:pPr>
+            <a:r>
+              <a:rPr lang="en-US" sz="2800" b="1" dirty="0">
+                <a:solidFill>
+                  <a:srgbClr val="111111"/>
+                </a:solidFill>
+                <a:latin typeface="Times New Roman" pitchFamily="34" charset="0"/>
+                <a:ea typeface="Times New Roman" pitchFamily="34" charset="-122"/>
+                <a:cs typeface="Times New Roman" pitchFamily="34" charset="-120"/>
+              </a:rPr>
+              <a:t>Tropical continental air (cT): </a:t>
+            </a:r>
+            <a:pPr algn="l" indent="0" marL="0">
+              <a:spcAft>
+                <a:spcPts val="800"/>
+              </a:spcAft>
+              <a:buNone/>
+            </a:pPr>
+            <a:r>
+              <a:rPr lang="en-US" sz="2800" dirty="0">
+                <a:solidFill>
+                  <a:srgbClr val="111111"/>
+                </a:solidFill>
+                <a:latin typeface="Times New Roman" pitchFamily="34" charset="0"/>
+                <a:ea typeface="Times New Roman" pitchFamily="34" charset="-122"/>
+                <a:cs typeface="Times New Roman" pitchFamily="34" charset="-120"/>
+              </a:rPr>
+              <a:t>It forms over the Sahara and is hot by day, very dry, dusty and stable, blowing as the north-east Harmattan. It dominates the dry season in Garoua from about November to March, with sunshine, haze and low humidity.</a:t>
+            </a:r>
+            <a:endParaRPr lang="en-US" sz="2800" dirty="0"/>
           </a:p>
         </p:txBody>
       </p:sp>
       <p:pic>
         <p:nvPicPr>
-          <p:cNvPr id="3" name="Image 0" descr="/home/claude/f4/img/minesec_sheet.png">    </p:cNvPr>
+          <p:cNvPr id="5" name="Image 0" descr="/home/claude/f4/img/v2/f2t_harmattan.jpg">    </p:cNvPr>
           <p:cNvPicPr>
             <a:picLocks noChangeAspect="1"/>
           </p:cNvPicPr>
@@ -19988,8 +20494,8 @@
         </p:blipFill>
         <p:spPr>
           <a:xfrm>
-            <a:off x="0" y="658368"/>
-            <a:ext cx="5120640" cy="5833872"/>
+            <a:off x="6537960" y="2400897"/>
+            <a:ext cx="5470855" cy="3034615"/>
           </a:xfrm>
           <a:prstGeom prst="rect">
             <a:avLst/>
@@ -19998,14 +20504,14 @@
       </p:pic>
       <p:sp>
         <p:nvSpPr>
-          <p:cNvPr id="4" name="Text 1"/>
+          <p:cNvPr id="6" name="Text 3"/>
           <p:cNvSpPr/>
           <p:nvPr/>
         </p:nvSpPr>
         <p:spPr>
           <a:xfrm>
-            <a:off x="5349240" y="1005840"/>
-            <a:ext cx="6522415" cy="731520"/>
+            <a:off x="6537960" y="6089904"/>
+            <a:ext cx="5470855" cy="347472"/>
           </a:xfrm>
           <a:prstGeom prst="rect">
             <a:avLst/>
@@ -20014,68 +20520,24 @@
           <a:ln/>
         </p:spPr>
         <p:txBody>
-          <a:bodyPr wrap="square" lIns="0" tIns="0" rIns="0" bIns="0" rtlCol="0" anchor="ctr">
-            <a:normAutofit/>
-          </a:bodyPr>
+          <a:bodyPr wrap="square" lIns="0" tIns="0" rIns="0" bIns="0" rtlCol="0" anchor="ctr"/>
           <a:lstStyle/>
           <a:p>
             <a:pPr algn="ctr" indent="0" marL="0">
               <a:buNone/>
             </a:pPr>
             <a:r>
-              <a:rPr lang="en-US" sz="3600" b="1" dirty="0">
-                <a:solidFill>
-                  <a:srgbClr val="990011"/>
+              <a:rPr lang="en-US" sz="1600" i="1" dirty="0">
+                <a:solidFill>
+                  <a:srgbClr val="555555"/>
                 </a:solidFill>
                 <a:latin typeface="Times New Roman" pitchFamily="34" charset="0"/>
                 <a:ea typeface="Times New Roman" pitchFamily="34" charset="-122"/>
                 <a:cs typeface="Times New Roman" pitchFamily="34" charset="-120"/>
               </a:rPr>
-              <a:t>Evaluation 1</a:t>
-            </a:r>
-            <a:endParaRPr lang="en-US" sz="3600" dirty="0"/>
-          </a:p>
-        </p:txBody>
-      </p:sp>
-      <p:sp>
-        <p:nvSpPr>
-          <p:cNvPr id="5" name="Text 2"/>
-          <p:cNvSpPr/>
-          <p:nvPr/>
-        </p:nvSpPr>
-        <p:spPr>
-          <a:xfrm>
-            <a:off x="5349240" y="1783080"/>
-            <a:ext cx="6522415" cy="4663440"/>
-          </a:xfrm>
-          <a:prstGeom prst="rect">
-            <a:avLst/>
-          </a:prstGeom>
-          <a:noFill/>
-          <a:ln/>
-        </p:spPr>
-        <p:txBody>
-          <a:bodyPr wrap="square" lIns="0" tIns="0" rIns="0" bIns="0" rtlCol="0" anchor="t"/>
-          <a:lstStyle/>
-          <a:p>
-            <a:pPr algn="l" indent="0" marL="0">
-              <a:spcAft>
-                <a:spcPts val="800"/>
-              </a:spcAft>
-              <a:buNone/>
-            </a:pPr>
-            <a:r>
-              <a:rPr lang="en-US" sz="4000" dirty="0">
-                <a:solidFill>
-                  <a:srgbClr val="111111"/>
-                </a:solidFill>
-                <a:latin typeface="Times New Roman" pitchFamily="34" charset="0"/>
-                <a:ea typeface="Times New Roman" pitchFamily="34" charset="-122"/>
-                <a:cs typeface="Times New Roman" pitchFamily="34" charset="-120"/>
-              </a:rPr>
-              <a:t>Distinguish a continental air mass from a maritime air mass.</a:t>
-            </a:r>
-            <a:endParaRPr lang="en-US" sz="4000" dirty="0"/>
+              <a:t>Illustration: the Harmattan</a:t>
+            </a:r>
+            <a:endParaRPr lang="en-US" sz="1600" dirty="0"/>
           </a:p>
         </p:txBody>
       </p:sp>
@@ -20185,15 +20647,115 @@
                 <a:ea typeface="Calibri" pitchFamily="34" charset="-122"/>
                 <a:cs typeface="Calibri" pitchFamily="34" charset="-120"/>
               </a:rPr>
-              <a:t>FORMATIVE EVALUATION</a:t>
+              <a:t>BOARD SUMMARY</a:t>
             </a:r>
             <a:endParaRPr lang="en-US" sz="1400" dirty="0"/>
+          </a:p>
+        </p:txBody>
+      </p:sp>
+      <p:sp>
+        <p:nvSpPr>
+          <p:cNvPr id="3" name="Text 1"/>
+          <p:cNvSpPr/>
+          <p:nvPr/>
+        </p:nvSpPr>
+        <p:spPr>
+          <a:xfrm>
+            <a:off x="365760" y="1005840"/>
+            <a:ext cx="11460175" cy="731520"/>
+          </a:xfrm>
+          <a:prstGeom prst="rect">
+            <a:avLst/>
+          </a:prstGeom>
+          <a:noFill/>
+          <a:ln/>
+        </p:spPr>
+        <p:txBody>
+          <a:bodyPr wrap="square" lIns="0" tIns="0" rIns="0" bIns="0" rtlCol="0" anchor="ctr">
+            <a:normAutofit/>
+          </a:bodyPr>
+          <a:lstStyle/>
+          <a:p>
+            <a:pPr algn="ctr" indent="0" marL="0">
+              <a:buNone/>
+            </a:pPr>
+            <a:r>
+              <a:rPr lang="en-US" sz="3600" b="1" dirty="0">
+                <a:solidFill>
+                  <a:srgbClr val="990011"/>
+                </a:solidFill>
+                <a:latin typeface="Times New Roman" pitchFamily="34" charset="0"/>
+                <a:ea typeface="Times New Roman" pitchFamily="34" charset="-122"/>
+                <a:cs typeface="Times New Roman" pitchFamily="34" charset="-120"/>
+              </a:rPr>
+              <a:t>5. Air Masses Affecting Cameroon and West Africa</a:t>
+            </a:r>
+            <a:endParaRPr lang="en-US" sz="3600" dirty="0"/>
+          </a:p>
+        </p:txBody>
+      </p:sp>
+      <p:sp>
+        <p:nvSpPr>
+          <p:cNvPr id="4" name="Text 2"/>
+          <p:cNvSpPr/>
+          <p:nvPr/>
+        </p:nvSpPr>
+        <p:spPr>
+          <a:xfrm>
+            <a:off x="365760" y="1783080"/>
+            <a:ext cx="6035040" cy="4617720"/>
+          </a:xfrm>
+          <a:prstGeom prst="rect">
+            <a:avLst/>
+          </a:prstGeom>
+          <a:noFill/>
+          <a:ln/>
+        </p:spPr>
+        <p:txBody>
+          <a:bodyPr wrap="square" lIns="0" tIns="0" rIns="0" bIns="0" rtlCol="0" anchor="t"/>
+          <a:lstStyle/>
+          <a:p>
+            <a:pPr algn="l" indent="0" marL="0">
+              <a:spcAft>
+                <a:spcPts val="800"/>
+              </a:spcAft>
+              <a:buNone/>
+            </a:pPr>
+            <a:r>
+              <a:rPr lang="en-US" sz="3200" b="1" dirty="0">
+                <a:solidFill>
+                  <a:srgbClr val="111111"/>
+                </a:solidFill>
+                <a:latin typeface="Times New Roman" pitchFamily="34" charset="0"/>
+                <a:ea typeface="Times New Roman" pitchFamily="34" charset="-122"/>
+                <a:cs typeface="Times New Roman" pitchFamily="34" charset="-120"/>
+              </a:rPr>
+              <a:t>Tropical maritime air (mT): </a:t>
+            </a:r>
+            <a:pPr algn="l" indent="0" marL="0">
+              <a:spcAft>
+                <a:spcPts val="800"/>
+              </a:spcAft>
+              <a:buNone/>
+            </a:pPr>
+            <a:r>
+              <a:rPr lang="en-US" sz="3200" dirty="0">
+                <a:solidFill>
+                  <a:srgbClr val="111111"/>
+                </a:solidFill>
+                <a:latin typeface="Times New Roman" pitchFamily="34" charset="0"/>
+                <a:ea typeface="Times New Roman" pitchFamily="34" charset="-122"/>
+                <a:cs typeface="Times New Roman" pitchFamily="34" charset="-120"/>
+              </a:rPr>
+              <a:t>It forms over the South Atlantic Ocean around Saint Helena and is warm, very moist and unstable, blowing as the south-west monsoon. It brings the rainy season to Garoua from about May to October, with cumulonimbus clouds and storms.</a:t>
+            </a:r>
+            <a:endParaRPr lang="en-US" sz="3200" dirty="0"/>
           </a:p>
         </p:txBody>
       </p:sp>
       <p:pic>
         <p:nvPicPr>
-          <p:cNvPr id="3" name="Image 0" descr="/home/claude/f4/img/minesec_sheet.png">    </p:cNvPr>
+          <p:cNvPr id="5" name="Image 0" descr="/home/claude/f4/img/v2/f4_heavyrain.jpg">    </p:cNvPr>
           <p:cNvPicPr>
             <a:picLocks noChangeAspect="1"/>
           </p:cNvPicPr>
@@ -20207,8 +20769,8 @@
         </p:blipFill>
         <p:spPr>
           <a:xfrm>
-            <a:off x="0" y="658368"/>
-            <a:ext cx="5120640" cy="5833872"/>
+            <a:off x="6537960" y="2400897"/>
+            <a:ext cx="5470855" cy="3034615"/>
           </a:xfrm>
           <a:prstGeom prst="rect">
             <a:avLst/>
@@ -20217,14 +20779,14 @@
       </p:pic>
       <p:sp>
         <p:nvSpPr>
-          <p:cNvPr id="4" name="Text 1"/>
+          <p:cNvPr id="6" name="Text 3"/>
           <p:cNvSpPr/>
           <p:nvPr/>
         </p:nvSpPr>
         <p:spPr>
           <a:xfrm>
-            <a:off x="5349240" y="1005840"/>
-            <a:ext cx="6522415" cy="731520"/>
+            <a:off x="6537960" y="6089904"/>
+            <a:ext cx="5470855" cy="347472"/>
           </a:xfrm>
           <a:prstGeom prst="rect">
             <a:avLst/>
@@ -20233,68 +20795,24 @@
           <a:ln/>
         </p:spPr>
         <p:txBody>
-          <a:bodyPr wrap="square" lIns="0" tIns="0" rIns="0" bIns="0" rtlCol="0" anchor="ctr">
-            <a:normAutofit/>
-          </a:bodyPr>
+          <a:bodyPr wrap="square" lIns="0" tIns="0" rIns="0" bIns="0" rtlCol="0" anchor="ctr"/>
           <a:lstStyle/>
           <a:p>
             <a:pPr algn="ctr" indent="0" marL="0">
               <a:buNone/>
             </a:pPr>
             <a:r>
-              <a:rPr lang="en-US" sz="3600" b="1" dirty="0">
-                <a:solidFill>
-                  <a:srgbClr val="990011"/>
+              <a:rPr lang="en-US" sz="1600" i="1" dirty="0">
+                <a:solidFill>
+                  <a:srgbClr val="555555"/>
                 </a:solidFill>
                 <a:latin typeface="Times New Roman" pitchFamily="34" charset="0"/>
                 <a:ea typeface="Times New Roman" pitchFamily="34" charset="-122"/>
                 <a:cs typeface="Times New Roman" pitchFamily="34" charset="-120"/>
               </a:rPr>
-              <a:t>Expected Answer</a:t>
-            </a:r>
-            <a:endParaRPr lang="en-US" sz="3600" dirty="0"/>
-          </a:p>
-        </p:txBody>
-      </p:sp>
-      <p:sp>
-        <p:nvSpPr>
-          <p:cNvPr id="5" name="Text 2"/>
-          <p:cNvSpPr/>
-          <p:nvPr/>
-        </p:nvSpPr>
-        <p:spPr>
-          <a:xfrm>
-            <a:off x="5349240" y="1783080"/>
-            <a:ext cx="6522415" cy="4663440"/>
-          </a:xfrm>
-          <a:prstGeom prst="rect">
-            <a:avLst/>
-          </a:prstGeom>
-          <a:noFill/>
-          <a:ln/>
-        </p:spPr>
-        <p:txBody>
-          <a:bodyPr wrap="square" lIns="0" tIns="0" rIns="0" bIns="0" rtlCol="0" anchor="t"/>
-          <a:lstStyle/>
-          <a:p>
-            <a:pPr algn="l" indent="0" marL="0">
-              <a:spcAft>
-                <a:spcPts val="800"/>
-              </a:spcAft>
-              <a:buNone/>
-            </a:pPr>
-            <a:r>
-              <a:rPr lang="en-US" sz="4000" dirty="0">
-                <a:solidFill>
-                  <a:srgbClr val="111111"/>
-                </a:solidFill>
-                <a:latin typeface="Times New Roman" pitchFamily="34" charset="0"/>
-                <a:ea typeface="Times New Roman" pitchFamily="34" charset="-122"/>
-                <a:cs typeface="Times New Roman" pitchFamily="34" charset="-120"/>
-              </a:rPr>
-              <a:t>A continental air mass forms over land and is dry; a maritime air mass forms over the sea and is moist.</a:t>
-            </a:r>
-            <a:endParaRPr lang="en-US" sz="4000" dirty="0"/>
+              <a:t>Illustration: heavy rain</a:t>
+            </a:r>
+            <a:endParaRPr lang="en-US" sz="1600" dirty="0"/>
           </a:p>
         </p:txBody>
       </p:sp>
@@ -20404,15 +20922,115 @@
                 <a:ea typeface="Calibri" pitchFamily="34" charset="-122"/>
                 <a:cs typeface="Calibri" pitchFamily="34" charset="-120"/>
               </a:rPr>
-              <a:t>FORMATIVE EVALUATION</a:t>
+              <a:t>BOARD SUMMARY</a:t>
             </a:r>
             <a:endParaRPr lang="en-US" sz="1400" dirty="0"/>
+          </a:p>
+        </p:txBody>
+      </p:sp>
+      <p:sp>
+        <p:nvSpPr>
+          <p:cNvPr id="3" name="Text 1"/>
+          <p:cNvSpPr/>
+          <p:nvPr/>
+        </p:nvSpPr>
+        <p:spPr>
+          <a:xfrm>
+            <a:off x="365760" y="1005840"/>
+            <a:ext cx="11460175" cy="731520"/>
+          </a:xfrm>
+          <a:prstGeom prst="rect">
+            <a:avLst/>
+          </a:prstGeom>
+          <a:noFill/>
+          <a:ln/>
+        </p:spPr>
+        <p:txBody>
+          <a:bodyPr wrap="square" lIns="0" tIns="0" rIns="0" bIns="0" rtlCol="0" anchor="ctr">
+            <a:normAutofit/>
+          </a:bodyPr>
+          <a:lstStyle/>
+          <a:p>
+            <a:pPr algn="ctr" indent="0" marL="0">
+              <a:buNone/>
+            </a:pPr>
+            <a:r>
+              <a:rPr lang="en-US" sz="3600" b="1" dirty="0">
+                <a:solidFill>
+                  <a:srgbClr val="990011"/>
+                </a:solidFill>
+                <a:latin typeface="Times New Roman" pitchFamily="34" charset="0"/>
+                <a:ea typeface="Times New Roman" pitchFamily="34" charset="-122"/>
+                <a:cs typeface="Times New Roman" pitchFamily="34" charset="-120"/>
+              </a:rPr>
+              <a:t>5. Air Masses Affecting Cameroon and West Africa</a:t>
+            </a:r>
+            <a:endParaRPr lang="en-US" sz="3600" dirty="0"/>
+          </a:p>
+        </p:txBody>
+      </p:sp>
+      <p:sp>
+        <p:nvSpPr>
+          <p:cNvPr id="4" name="Text 2"/>
+          <p:cNvSpPr/>
+          <p:nvPr/>
+        </p:nvSpPr>
+        <p:spPr>
+          <a:xfrm>
+            <a:off x="365760" y="1783080"/>
+            <a:ext cx="6035040" cy="4617720"/>
+          </a:xfrm>
+          <a:prstGeom prst="rect">
+            <a:avLst/>
+          </a:prstGeom>
+          <a:noFill/>
+          <a:ln/>
+        </p:spPr>
+        <p:txBody>
+          <a:bodyPr wrap="square" lIns="0" tIns="0" rIns="0" bIns="0" rtlCol="0" anchor="t"/>
+          <a:lstStyle/>
+          <a:p>
+            <a:pPr algn="l" indent="0" marL="0">
+              <a:spcAft>
+                <a:spcPts val="800"/>
+              </a:spcAft>
+              <a:buNone/>
+            </a:pPr>
+            <a:r>
+              <a:rPr lang="en-US" sz="3200" b="1" dirty="0">
+                <a:solidFill>
+                  <a:srgbClr val="111111"/>
+                </a:solidFill>
+                <a:latin typeface="Times New Roman" pitchFamily="34" charset="0"/>
+                <a:ea typeface="Times New Roman" pitchFamily="34" charset="-122"/>
+                <a:cs typeface="Times New Roman" pitchFamily="34" charset="-120"/>
+              </a:rPr>
+              <a:t>The Intertropical Front (ITF): </a:t>
+            </a:r>
+            <a:pPr algn="l" indent="0" marL="0">
+              <a:spcAft>
+                <a:spcPts val="800"/>
+              </a:spcAft>
+              <a:buNone/>
+            </a:pPr>
+            <a:r>
+              <a:rPr lang="en-US" sz="3200" dirty="0">
+                <a:solidFill>
+                  <a:srgbClr val="111111"/>
+                </a:solidFill>
+                <a:latin typeface="Times New Roman" pitchFamily="34" charset="0"/>
+                <a:ea typeface="Times New Roman" pitchFamily="34" charset="-122"/>
+                <a:cs typeface="Times New Roman" pitchFamily="34" charset="-120"/>
+              </a:rPr>
+              <a:t>The two air masses meet along the ITF, which moves north in the northern summer and south in winter. Places south of the ITF receive rain, which explains why the rainy season is longer in the south of Cameroon than in the north.</a:t>
+            </a:r>
+            <a:endParaRPr lang="en-US" sz="3200" dirty="0"/>
           </a:p>
         </p:txBody>
       </p:sp>
       <p:pic>
         <p:nvPicPr>
-          <p:cNvPr id="3" name="Image 0" descr="/home/claude/f4/img/minesec_sheet.png">    </p:cNvPr>
+          <p:cNvPr id="5" name="Image 0" descr="/home/claude/f4/img/v2/wa_airmasses_big.png">    </p:cNvPr>
           <p:cNvPicPr>
             <a:picLocks noChangeAspect="1"/>
           </p:cNvPicPr>
@@ -20426,8 +21044,8 @@
         </p:blipFill>
         <p:spPr>
           <a:xfrm>
-            <a:off x="0" y="658368"/>
-            <a:ext cx="5120640" cy="5833872"/>
+            <a:off x="6537960" y="2550490"/>
+            <a:ext cx="5470855" cy="2735428"/>
           </a:xfrm>
           <a:prstGeom prst="rect">
             <a:avLst/>
@@ -20436,14 +21054,14 @@
       </p:pic>
       <p:sp>
         <p:nvSpPr>
-          <p:cNvPr id="4" name="Text 1"/>
+          <p:cNvPr id="6" name="Text 3"/>
           <p:cNvSpPr/>
           <p:nvPr/>
         </p:nvSpPr>
         <p:spPr>
           <a:xfrm>
-            <a:off x="5349240" y="1005840"/>
-            <a:ext cx="6522415" cy="731520"/>
+            <a:off x="6537960" y="6089904"/>
+            <a:ext cx="5470855" cy="347472"/>
           </a:xfrm>
           <a:prstGeom prst="rect">
             <a:avLst/>
@@ -20452,68 +21070,24 @@
           <a:ln/>
         </p:spPr>
         <p:txBody>
-          <a:bodyPr wrap="square" lIns="0" tIns="0" rIns="0" bIns="0" rtlCol="0" anchor="ctr">
-            <a:normAutofit/>
-          </a:bodyPr>
+          <a:bodyPr wrap="square" lIns="0" tIns="0" rIns="0" bIns="0" rtlCol="0" anchor="ctr"/>
           <a:lstStyle/>
           <a:p>
             <a:pPr algn="ctr" indent="0" marL="0">
               <a:buNone/>
             </a:pPr>
             <a:r>
-              <a:rPr lang="en-US" sz="3600" b="1" dirty="0">
-                <a:solidFill>
-                  <a:srgbClr val="990011"/>
+              <a:rPr lang="en-US" sz="1600" i="1" dirty="0">
+                <a:solidFill>
+                  <a:srgbClr val="555555"/>
                 </a:solidFill>
                 <a:latin typeface="Times New Roman" pitchFamily="34" charset="0"/>
                 <a:ea typeface="Times New Roman" pitchFamily="34" charset="-122"/>
                 <a:cs typeface="Times New Roman" pitchFamily="34" charset="-120"/>
               </a:rPr>
-              <a:t>Evaluation 2</a:t>
-            </a:r>
-            <a:endParaRPr lang="en-US" sz="3600" dirty="0"/>
-          </a:p>
-        </p:txBody>
-      </p:sp>
-      <p:sp>
-        <p:nvSpPr>
-          <p:cNvPr id="5" name="Text 2"/>
-          <p:cNvSpPr/>
-          <p:nvPr/>
-        </p:nvSpPr>
-        <p:spPr>
-          <a:xfrm>
-            <a:off x="5349240" y="1783080"/>
-            <a:ext cx="6522415" cy="4663440"/>
-          </a:xfrm>
-          <a:prstGeom prst="rect">
-            <a:avLst/>
-          </a:prstGeom>
-          <a:noFill/>
-          <a:ln/>
-        </p:spPr>
-        <p:txBody>
-          <a:bodyPr wrap="square" lIns="0" tIns="0" rIns="0" bIns="0" rtlCol="0" anchor="t"/>
-          <a:lstStyle/>
-          <a:p>
-            <a:pPr algn="l" indent="0" marL="0">
-              <a:spcAft>
-                <a:spcPts val="800"/>
-              </a:spcAft>
-              <a:buNone/>
-            </a:pPr>
-            <a:r>
-              <a:rPr lang="en-US" sz="4000" dirty="0">
-                <a:solidFill>
-                  <a:srgbClr val="111111"/>
-                </a:solidFill>
-                <a:latin typeface="Times New Roman" pitchFamily="34" charset="0"/>
-                <a:ea typeface="Times New Roman" pitchFamily="34" charset="-122"/>
-                <a:cs typeface="Times New Roman" pitchFamily="34" charset="-120"/>
-              </a:rPr>
-              <a:t>Which air mass brings the rainy season to Garoua, and why?</a:t>
-            </a:r>
-            <a:endParaRPr lang="en-US" sz="4000" dirty="0"/>
+              <a:t>Illustration: the air masses of West Africa</a:t>
+            </a:r>
+            <a:endParaRPr lang="en-US" sz="1600" dirty="0"/>
           </a:p>
         </p:txBody>
       </p:sp>
@@ -20688,7 +21262,7 @@
                 <a:ea typeface="Times New Roman" pitchFamily="34" charset="-122"/>
                 <a:cs typeface="Times New Roman" pitchFamily="34" charset="-120"/>
               </a:rPr>
-              <a:t>Expected Answer</a:t>
+              <a:t>Evaluation 1</a:t>
             </a:r>
             <a:endParaRPr lang="en-US" sz="3600" dirty="0"/>
           </a:p>
@@ -20730,7 +21304,7 @@
                 <a:ea typeface="Times New Roman" pitchFamily="34" charset="-122"/>
                 <a:cs typeface="Times New Roman" pitchFamily="34" charset="-120"/>
               </a:rPr>
-              <a:t>The tropical maritime (mT) air mass, because it is moist and unstable.</a:t>
+              <a:t>Distinguish a continental air mass from a maritime air mass.</a:t>
             </a:r>
             <a:endParaRPr lang="en-US" sz="4000" dirty="0"/>
           </a:p>
@@ -20842,7 +21416,7 @@
                 <a:ea typeface="Calibri" pitchFamily="34" charset="-122"/>
                 <a:cs typeface="Calibri" pitchFamily="34" charset="-120"/>
               </a:rPr>
-              <a:t>REMEDIATION</a:t>
+              <a:t>FORMATIVE EVALUATION</a:t>
             </a:r>
             <a:endParaRPr lang="en-US" sz="1400" dirty="0"/>
           </a:p>
@@ -20865,7 +21439,7 @@
         <p:spPr>
           <a:xfrm>
             <a:off x="0" y="658368"/>
-            <a:ext cx="2468880" cy="5833872"/>
+            <a:ext cx="5120640" cy="5833872"/>
           </a:xfrm>
           <a:prstGeom prst="rect">
             <a:avLst/>
@@ -20880,8 +21454,8 @@
         </p:nvSpPr>
         <p:spPr>
           <a:xfrm>
-            <a:off x="2697480" y="1005840"/>
-            <a:ext cx="9174175" cy="731520"/>
+            <a:off x="5349240" y="1005840"/>
+            <a:ext cx="6522415" cy="731520"/>
           </a:xfrm>
           <a:prstGeom prst="rect">
             <a:avLst/>
@@ -20907,7 +21481,7 @@
                 <a:ea typeface="Times New Roman" pitchFamily="34" charset="-122"/>
                 <a:cs typeface="Times New Roman" pitchFamily="34" charset="-120"/>
               </a:rPr>
-              <a:t>Remediation</a:t>
+              <a:t>Expected Answer</a:t>
             </a:r>
             <a:endParaRPr lang="en-US" sz="3600" dirty="0"/>
           </a:p>
@@ -20921,8 +21495,8 @@
         </p:nvSpPr>
         <p:spPr>
           <a:xfrm>
-            <a:off x="2697480" y="1783080"/>
-            <a:ext cx="9174175" cy="4663440"/>
+            <a:off x="5349240" y="1783080"/>
+            <a:ext cx="6522415" cy="4663440"/>
           </a:xfrm>
           <a:prstGeom prst="rect">
             <a:avLst/>
@@ -20941,7 +21515,7 @@
               <a:buNone/>
             </a:pPr>
             <a:r>
-              <a:rPr lang="en-US" sz="4000" b="1" dirty="0">
+              <a:rPr lang="en-US" sz="4000" dirty="0">
                 <a:solidFill>
                   <a:srgbClr val="111111"/>
                 </a:solidFill>
@@ -20949,73 +21523,7 @@
                 <a:ea typeface="Times New Roman" pitchFamily="34" charset="-122"/>
                 <a:cs typeface="Times New Roman" pitchFamily="34" charset="-120"/>
               </a:rPr>
-              <a:t>Fill in the blanks:</a:t>
-            </a:r>
-            <a:endParaRPr lang="en-US" sz="4000" dirty="0"/>
-          </a:p>
-          <a:p>
-            <a:pPr algn="l" marL="342900" indent="-342900">
-              <a:spcAft>
-                <a:spcPts val="800"/>
-              </a:spcAft>
-              <a:buSzPct val="100000"/>
-              <a:buFont typeface="+mj-lt"/>
-              <a:buAutoNum type="arabicPeriod" startAt="1"/>
-            </a:pPr>
-            <a:r>
-              <a:rPr lang="en-US" sz="4000" dirty="0">
-                <a:solidFill>
-                  <a:srgbClr val="111111"/>
-                </a:solidFill>
-                <a:latin typeface="Times New Roman" pitchFamily="34" charset="0"/>
-                <a:ea typeface="Times New Roman" pitchFamily="34" charset="-122"/>
-                <a:cs typeface="Times New Roman" pitchFamily="34" charset="-120"/>
-              </a:rPr>
-              <a:t>An air mass takes its characteristics from its ______ region.</a:t>
-            </a:r>
-            <a:endParaRPr lang="en-US" sz="4000" dirty="0"/>
-          </a:p>
-          <a:p>
-            <a:pPr algn="l" marL="342900" indent="-342900">
-              <a:spcAft>
-                <a:spcPts val="800"/>
-              </a:spcAft>
-              <a:buSzPct val="100000"/>
-              <a:buFont typeface="+mj-lt"/>
-              <a:buAutoNum type="arabicPeriod" startAt="1"/>
-            </a:pPr>
-            <a:r>
-              <a:rPr lang="en-US" sz="4000" dirty="0">
-                <a:solidFill>
-                  <a:srgbClr val="111111"/>
-                </a:solidFill>
-                <a:latin typeface="Times New Roman" pitchFamily="34" charset="0"/>
-                <a:ea typeface="Times New Roman" pitchFamily="34" charset="-122"/>
-                <a:cs typeface="Times New Roman" pitchFamily="34" charset="-120"/>
-              </a:rPr>
-              <a:t>The Harmattan is a ______ air mass.</a:t>
-            </a:r>
-            <a:endParaRPr lang="en-US" sz="4000" dirty="0"/>
-          </a:p>
-          <a:p>
-            <a:pPr algn="l" marL="342900" indent="-342900">
-              <a:spcAft>
-                <a:spcPts val="800"/>
-              </a:spcAft>
-              <a:buSzPct val="100000"/>
-              <a:buFont typeface="+mj-lt"/>
-              <a:buAutoNum type="arabicPeriod" startAt="1"/>
-            </a:pPr>
-            <a:r>
-              <a:rPr lang="en-US" sz="4000" dirty="0">
-                <a:solidFill>
-                  <a:srgbClr val="111111"/>
-                </a:solidFill>
-                <a:latin typeface="Times New Roman" pitchFamily="34" charset="0"/>
-                <a:ea typeface="Times New Roman" pitchFamily="34" charset="-122"/>
-                <a:cs typeface="Times New Roman" pitchFamily="34" charset="-120"/>
-              </a:rPr>
-              <a:t>The two air masses meet at the ______.</a:t>
+              <a:t>A continental air mass forms over land and is dry; a maritime air mass forms over the sea and is moist.</a:t>
             </a:r>
             <a:endParaRPr lang="en-US" sz="4000" dirty="0"/>
           </a:p>
@@ -21127,7 +21635,7 @@
                 <a:ea typeface="Calibri" pitchFamily="34" charset="-122"/>
                 <a:cs typeface="Calibri" pitchFamily="34" charset="-120"/>
               </a:rPr>
-              <a:t>HOMEWORK</a:t>
+              <a:t>FORMATIVE EVALUATION</a:t>
             </a:r>
             <a:endParaRPr lang="en-US" sz="1400" dirty="0"/>
           </a:p>
@@ -21192,7 +21700,7 @@
                 <a:ea typeface="Times New Roman" pitchFamily="34" charset="-122"/>
                 <a:cs typeface="Times New Roman" pitchFamily="34" charset="-120"/>
               </a:rPr>
-              <a:t>Homework</a:t>
+              <a:t>Evaluation 2</a:t>
             </a:r>
             <a:endParaRPr lang="en-US" sz="3600" dirty="0"/>
           </a:p>
@@ -21234,7 +21742,7 @@
                 <a:ea typeface="Times New Roman" pitchFamily="34" charset="-122"/>
                 <a:cs typeface="Times New Roman" pitchFamily="34" charset="-120"/>
               </a:rPr>
-              <a:t>Define climate.</a:t>
+              <a:t>Which air mass brings the rainy season to Garoua, and why?</a:t>
             </a:r>
             <a:endParaRPr lang="en-US" sz="4000" dirty="0"/>
           </a:p>
@@ -21677,7 +22185,7 @@
                 <a:ea typeface="Calibri" pitchFamily="34" charset="-122"/>
                 <a:cs typeface="Calibri" pitchFamily="34" charset="-120"/>
               </a:rPr>
-              <a:t>NEXT LESSON</a:t>
+              <a:t>FORMATIVE EVALUATION</a:t>
             </a:r>
             <a:endParaRPr lang="en-US" sz="1400" dirty="0"/>
           </a:p>
@@ -21742,7 +22250,7 @@
                 <a:ea typeface="Times New Roman" pitchFamily="34" charset="-122"/>
                 <a:cs typeface="Times New Roman" pitchFamily="34" charset="-120"/>
               </a:rPr>
-              <a:t>Next Lesson</a:t>
+              <a:t>Expected Answer</a:t>
             </a:r>
             <a:endParaRPr lang="en-US" sz="3600" dirty="0"/>
           </a:p>
@@ -21766,17 +22274,17 @@
           <a:ln/>
         </p:spPr>
         <p:txBody>
-          <a:bodyPr wrap="square" lIns="0" tIns="0" rIns="0" bIns="0" rtlCol="0" anchor="ctr"/>
-          <a:lstStyle/>
-          <a:p>
-            <a:pPr algn="ctr" indent="0" marL="0">
+          <a:bodyPr wrap="square" lIns="0" tIns="0" rIns="0" bIns="0" rtlCol="0" anchor="t"/>
+          <a:lstStyle/>
+          <a:p>
+            <a:pPr algn="l" indent="0" marL="0">
               <a:spcAft>
                 <a:spcPts val="800"/>
               </a:spcAft>
               <a:buNone/>
             </a:pPr>
             <a:r>
-              <a:rPr lang="en-US" sz="4000" b="1" dirty="0">
+              <a:rPr lang="en-US" sz="4000" dirty="0">
                 <a:solidFill>
                   <a:srgbClr val="111111"/>
                 </a:solidFill>
@@ -21784,27 +22292,7 @@
                 <a:ea typeface="Times New Roman" pitchFamily="34" charset="-122"/>
                 <a:cs typeface="Times New Roman" pitchFamily="34" charset="-120"/>
               </a:rPr>
-              <a:t>Our next lesson will be on:</a:t>
-            </a:r>
-            <a:endParaRPr lang="en-US" sz="4000" dirty="0"/>
-          </a:p>
-          <a:p>
-            <a:pPr algn="ctr" indent="0" marL="0">
-              <a:spcAft>
-                <a:spcPts val="800"/>
-              </a:spcAft>
-              <a:buNone/>
-            </a:pPr>
-            <a:r>
-              <a:rPr lang="en-US" sz="4000" b="1" dirty="0">
-                <a:solidFill>
-                  <a:srgbClr val="990011"/>
-                </a:solidFill>
-                <a:latin typeface="Times New Roman" pitchFamily="34" charset="0"/>
-                <a:ea typeface="Times New Roman" pitchFamily="34" charset="-122"/>
-                <a:cs typeface="Times New Roman" pitchFamily="34" charset="-120"/>
-              </a:rPr>
-              <a:t>Lesson 19: Meaning of Climate and Köppen's Classification</a:t>
+              <a:t>The tropical maritime (mT) air mass, because it is moist and unstable.</a:t>
             </a:r>
             <a:endParaRPr lang="en-US" sz="4000" dirty="0"/>
           </a:p>
@@ -21916,22 +22404,46 @@
                 <a:ea typeface="Calibri" pitchFamily="34" charset="-122"/>
                 <a:cs typeface="Calibri" pitchFamily="34" charset="-120"/>
               </a:rPr>
-              <a:t>BILINGUAL GAME</a:t>
+              <a:t>REMEDIATION</a:t>
             </a:r>
             <a:endParaRPr lang="en-US" sz="1400" dirty="0"/>
           </a:p>
         </p:txBody>
       </p:sp>
-      <p:sp>
-        <p:nvSpPr>
-          <p:cNvPr id="3" name="Text 1"/>
+      <p:pic>
+        <p:nvPicPr>
+          <p:cNvPr id="3" name="Image 0" descr="/home/claude/f4/img/minesec_sheet.png">    </p:cNvPr>
+          <p:cNvPicPr>
+            <a:picLocks noChangeAspect="1"/>
+          </p:cNvPicPr>
+          <p:nvPr/>
+        </p:nvPicPr>
+        <p:blipFill>
+          <a:blip r:embed="rId1"/>
+          <a:stretch>
+            <a:fillRect/>
+          </a:stretch>
+        </p:blipFill>
+        <p:spPr>
+          <a:xfrm>
+            <a:off x="0" y="658368"/>
+            <a:ext cx="2468880" cy="5833872"/>
+          </a:xfrm>
+          <a:prstGeom prst="rect">
+            <a:avLst/>
+          </a:prstGeom>
+        </p:spPr>
+      </p:pic>
+      <p:sp>
+        <p:nvSpPr>
+          <p:cNvPr id="4" name="Text 1"/>
           <p:cNvSpPr/>
           <p:nvPr/>
         </p:nvSpPr>
         <p:spPr>
           <a:xfrm>
-            <a:off x="457200" y="1005840"/>
-            <a:ext cx="11277295" cy="731520"/>
+            <a:off x="2697480" y="1005840"/>
+            <a:ext cx="9174175" cy="731520"/>
           </a:xfrm>
           <a:prstGeom prst="rect">
             <a:avLst/>
@@ -21940,7 +22452,9 @@
           <a:ln/>
         </p:spPr>
         <p:txBody>
-          <a:bodyPr wrap="square" lIns="0" tIns="0" rIns="0" bIns="0" rtlCol="0" anchor="ctr"/>
+          <a:bodyPr wrap="square" lIns="0" tIns="0" rIns="0" bIns="0" rtlCol="0" anchor="ctr">
+            <a:normAutofit/>
+          </a:bodyPr>
           <a:lstStyle/>
           <a:p>
             <a:pPr algn="ctr" indent="0" marL="0">
@@ -21955,6 +22469,723 @@
                 <a:ea typeface="Times New Roman" pitchFamily="34" charset="-122"/>
                 <a:cs typeface="Times New Roman" pitchFamily="34" charset="-120"/>
               </a:rPr>
+              <a:t>Remediation</a:t>
+            </a:r>
+            <a:endParaRPr lang="en-US" sz="3600" dirty="0"/>
+          </a:p>
+        </p:txBody>
+      </p:sp>
+      <p:sp>
+        <p:nvSpPr>
+          <p:cNvPr id="5" name="Text 2"/>
+          <p:cNvSpPr/>
+          <p:nvPr/>
+        </p:nvSpPr>
+        <p:spPr>
+          <a:xfrm>
+            <a:off x="2697480" y="1783080"/>
+            <a:ext cx="9174175" cy="4663440"/>
+          </a:xfrm>
+          <a:prstGeom prst="rect">
+            <a:avLst/>
+          </a:prstGeom>
+          <a:noFill/>
+          <a:ln/>
+        </p:spPr>
+        <p:txBody>
+          <a:bodyPr wrap="square" lIns="0" tIns="0" rIns="0" bIns="0" rtlCol="0" anchor="t"/>
+          <a:lstStyle/>
+          <a:p>
+            <a:pPr algn="l" indent="0" marL="0">
+              <a:spcAft>
+                <a:spcPts val="800"/>
+              </a:spcAft>
+              <a:buNone/>
+            </a:pPr>
+            <a:r>
+              <a:rPr lang="en-US" sz="4000" b="1" dirty="0">
+                <a:solidFill>
+                  <a:srgbClr val="111111"/>
+                </a:solidFill>
+                <a:latin typeface="Times New Roman" pitchFamily="34" charset="0"/>
+                <a:ea typeface="Times New Roman" pitchFamily="34" charset="-122"/>
+                <a:cs typeface="Times New Roman" pitchFamily="34" charset="-120"/>
+              </a:rPr>
+              <a:t>Fill in the blanks:</a:t>
+            </a:r>
+            <a:endParaRPr lang="en-US" sz="4000" dirty="0"/>
+          </a:p>
+          <a:p>
+            <a:pPr algn="l" marL="342900" indent="-342900">
+              <a:spcAft>
+                <a:spcPts val="800"/>
+              </a:spcAft>
+              <a:buSzPct val="100000"/>
+              <a:buFont typeface="+mj-lt"/>
+              <a:buAutoNum type="arabicPeriod" startAt="1"/>
+            </a:pPr>
+            <a:r>
+              <a:rPr lang="en-US" sz="4000" dirty="0">
+                <a:solidFill>
+                  <a:srgbClr val="111111"/>
+                </a:solidFill>
+                <a:latin typeface="Times New Roman" pitchFamily="34" charset="0"/>
+                <a:ea typeface="Times New Roman" pitchFamily="34" charset="-122"/>
+                <a:cs typeface="Times New Roman" pitchFamily="34" charset="-120"/>
+              </a:rPr>
+              <a:t>An air mass takes its characteristics from its ______ region.</a:t>
+            </a:r>
+            <a:endParaRPr lang="en-US" sz="4000" dirty="0"/>
+          </a:p>
+          <a:p>
+            <a:pPr algn="l" marL="342900" indent="-342900">
+              <a:spcAft>
+                <a:spcPts val="800"/>
+              </a:spcAft>
+              <a:buSzPct val="100000"/>
+              <a:buFont typeface="+mj-lt"/>
+              <a:buAutoNum type="arabicPeriod" startAt="1"/>
+            </a:pPr>
+            <a:r>
+              <a:rPr lang="en-US" sz="4000" dirty="0">
+                <a:solidFill>
+                  <a:srgbClr val="111111"/>
+                </a:solidFill>
+                <a:latin typeface="Times New Roman" pitchFamily="34" charset="0"/>
+                <a:ea typeface="Times New Roman" pitchFamily="34" charset="-122"/>
+                <a:cs typeface="Times New Roman" pitchFamily="34" charset="-120"/>
+              </a:rPr>
+              <a:t>The Harmattan is a ______ air mass.</a:t>
+            </a:r>
+            <a:endParaRPr lang="en-US" sz="4000" dirty="0"/>
+          </a:p>
+          <a:p>
+            <a:pPr algn="l" marL="342900" indent="-342900">
+              <a:spcAft>
+                <a:spcPts val="800"/>
+              </a:spcAft>
+              <a:buSzPct val="100000"/>
+              <a:buFont typeface="+mj-lt"/>
+              <a:buAutoNum type="arabicPeriod" startAt="1"/>
+            </a:pPr>
+            <a:r>
+              <a:rPr lang="en-US" sz="4000" dirty="0">
+                <a:solidFill>
+                  <a:srgbClr val="111111"/>
+                </a:solidFill>
+                <a:latin typeface="Times New Roman" pitchFamily="34" charset="0"/>
+                <a:ea typeface="Times New Roman" pitchFamily="34" charset="-122"/>
+                <a:cs typeface="Times New Roman" pitchFamily="34" charset="-120"/>
+              </a:rPr>
+              <a:t>The two air masses meet at the ______.</a:t>
+            </a:r>
+            <a:endParaRPr lang="en-US" sz="4000" dirty="0"/>
+          </a:p>
+        </p:txBody>
+      </p:sp>
+      <p:sp>
+        <p:nvSpPr>
+          <p:cNvPr id="25" name="Slide Number Placeholder 0"/>
+          <p:cNvSpPr>
+            <a:spLocks noGrp="1"/>
+          </p:cNvSpPr>
+          <p:nvPr>
+            <p:ph type="sldNum" sz="quarter" idx="4294967295"/>
+          </p:nvPr>
+        </p:nvSpPr>
+        <p:spPr>
+          <a:xfrm>
+            <a:off x="27432" y="91440"/>
+            <a:ext cx="585216" cy="475488"/>
+          </a:xfrm>
+          <a:prstGeom prst="rect">
+            <a:avLst/>
+          </a:prstGeom>
+          <a:extLst>
+            <a:ext uri="{C572A759-6A51-4108-AA02-DFA0A04FC94B}">
+              <ma14:wrappingTextBoxFlag xmlns:ma14="http://schemas.microsoft.com/office/mac/drawingml/2011/main" val="0"/>
+            </a:ext>
+          </a:extLst>
+        </p:spPr>
+        <p:txBody>
+          <a:bodyPr/>
+          <a:lstStyle>
+            <a:lvl1pPr>
+              <a:defRPr sz="2000">
+                <a:solidFill>
+                  <a:srgbClr val="FFFFFF"/>
+                </a:solidFill>
+                <a:latin typeface="Calibri"/>
+                <a:ea typeface="Calibri"/>
+                <a:cs typeface="Calibri"/>
+              </a:defRPr>
+            </a:lvl1pPr>
+          </a:lstStyle>
+          <a:p>
+            <a:pPr algn="ctr"/>
+            <a:fld id="{F7021451-1387-4CA6-816F-3879F97B5CBC}" type="slidenum">
+              <a:rPr b="1" lang="en-US"/>
+              <a:t>61</a:t>
+            </a:fld>
+            <a:endParaRPr lang="en-US"/>
+          </a:p>
+        </p:txBody>
+      </p:sp>
+    </p:spTree>
+  </p:cSld>
+  <p:clrMapOvr>
+    <a:masterClrMapping/>
+  </p:clrMapOvr>
+</p:sld>
+</file>
+
+<file path=ppt/slides/slide62.xml><?xml version="1.0" encoding="utf-8"?>
+<p:sld xmlns:a="http://schemas.openxmlformats.org/drawingml/2006/main" xmlns:r="http://schemas.openxmlformats.org/officeDocument/2006/relationships" xmlns:p="http://schemas.openxmlformats.org/presentationml/2006/main">
+  <p:cSld name="Slide 62">
+    <p:spTree>
+      <p:nvGrpSpPr>
+        <p:cNvPr id="1" name=""/>
+        <p:cNvGrpSpPr/>
+        <p:nvPr/>
+      </p:nvGrpSpPr>
+      <p:grpSpPr>
+        <a:xfrm>
+          <a:off x="0" y="0"/>
+          <a:ext cx="0" cy="0"/>
+          <a:chOff x="0" y="0"/>
+          <a:chExt cx="0" cy="0"/>
+        </a:xfrm>
+      </p:grpSpPr>
+      <p:sp>
+        <p:nvSpPr>
+          <p:cNvPr id="2" name="Text 0"/>
+          <p:cNvSpPr/>
+          <p:nvPr/>
+        </p:nvSpPr>
+        <p:spPr>
+          <a:xfrm>
+            <a:off x="457200" y="713232"/>
+            <a:ext cx="11368735" cy="274320"/>
+          </a:xfrm>
+          <a:prstGeom prst="rect">
+            <a:avLst/>
+          </a:prstGeom>
+          <a:noFill/>
+          <a:ln/>
+        </p:spPr>
+        <p:txBody>
+          <a:bodyPr wrap="square" lIns="0" tIns="0" rIns="0" bIns="0" rtlCol="0" anchor="ctr"/>
+          <a:lstStyle/>
+          <a:p>
+            <a:pPr algn="r" indent="0" marL="0">
+              <a:buNone/>
+            </a:pPr>
+            <a:r>
+              <a:rPr lang="en-US" sz="1400" b="1" dirty="0">
+                <a:solidFill>
+                  <a:srgbClr val="1C3F6E"/>
+                </a:solidFill>
+                <a:latin typeface="Calibri" pitchFamily="34" charset="0"/>
+                <a:ea typeface="Calibri" pitchFamily="34" charset="-122"/>
+                <a:cs typeface="Calibri" pitchFamily="34" charset="-120"/>
+              </a:rPr>
+              <a:t>HOMEWORK</a:t>
+            </a:r>
+            <a:endParaRPr lang="en-US" sz="1400" dirty="0"/>
+          </a:p>
+        </p:txBody>
+      </p:sp>
+      <p:pic>
+        <p:nvPicPr>
+          <p:cNvPr id="3" name="Image 0" descr="/home/claude/f4/img/minesec_sheet.png">    </p:cNvPr>
+          <p:cNvPicPr>
+            <a:picLocks noChangeAspect="1"/>
+          </p:cNvPicPr>
+          <p:nvPr/>
+        </p:nvPicPr>
+        <p:blipFill>
+          <a:blip r:embed="rId1"/>
+          <a:stretch>
+            <a:fillRect/>
+          </a:stretch>
+        </p:blipFill>
+        <p:spPr>
+          <a:xfrm>
+            <a:off x="0" y="658368"/>
+            <a:ext cx="5120640" cy="5833872"/>
+          </a:xfrm>
+          <a:prstGeom prst="rect">
+            <a:avLst/>
+          </a:prstGeom>
+        </p:spPr>
+      </p:pic>
+      <p:sp>
+        <p:nvSpPr>
+          <p:cNvPr id="4" name="Text 1"/>
+          <p:cNvSpPr/>
+          <p:nvPr/>
+        </p:nvSpPr>
+        <p:spPr>
+          <a:xfrm>
+            <a:off x="5349240" y="1005840"/>
+            <a:ext cx="6522415" cy="731520"/>
+          </a:xfrm>
+          <a:prstGeom prst="rect">
+            <a:avLst/>
+          </a:prstGeom>
+          <a:noFill/>
+          <a:ln/>
+        </p:spPr>
+        <p:txBody>
+          <a:bodyPr wrap="square" lIns="0" tIns="0" rIns="0" bIns="0" rtlCol="0" anchor="ctr">
+            <a:normAutofit/>
+          </a:bodyPr>
+          <a:lstStyle/>
+          <a:p>
+            <a:pPr algn="ctr" indent="0" marL="0">
+              <a:buNone/>
+            </a:pPr>
+            <a:r>
+              <a:rPr lang="en-US" sz="3600" b="1" dirty="0">
+                <a:solidFill>
+                  <a:srgbClr val="990011"/>
+                </a:solidFill>
+                <a:latin typeface="Times New Roman" pitchFamily="34" charset="0"/>
+                <a:ea typeface="Times New Roman" pitchFamily="34" charset="-122"/>
+                <a:cs typeface="Times New Roman" pitchFamily="34" charset="-120"/>
+              </a:rPr>
+              <a:t>Homework</a:t>
+            </a:r>
+            <a:endParaRPr lang="en-US" sz="3600" dirty="0"/>
+          </a:p>
+        </p:txBody>
+      </p:sp>
+      <p:sp>
+        <p:nvSpPr>
+          <p:cNvPr id="5" name="Text 2"/>
+          <p:cNvSpPr/>
+          <p:nvPr/>
+        </p:nvSpPr>
+        <p:spPr>
+          <a:xfrm>
+            <a:off x="5349240" y="1783080"/>
+            <a:ext cx="6522415" cy="4663440"/>
+          </a:xfrm>
+          <a:prstGeom prst="rect">
+            <a:avLst/>
+          </a:prstGeom>
+          <a:noFill/>
+          <a:ln/>
+        </p:spPr>
+        <p:txBody>
+          <a:bodyPr wrap="square" lIns="0" tIns="0" rIns="0" bIns="0" rtlCol="0" anchor="t"/>
+          <a:lstStyle/>
+          <a:p>
+            <a:pPr algn="l" indent="0" marL="0">
+              <a:spcAft>
+                <a:spcPts val="800"/>
+              </a:spcAft>
+              <a:buNone/>
+            </a:pPr>
+            <a:r>
+              <a:rPr lang="en-US" sz="4000" dirty="0">
+                <a:solidFill>
+                  <a:srgbClr val="111111"/>
+                </a:solidFill>
+                <a:latin typeface="Times New Roman" pitchFamily="34" charset="0"/>
+                <a:ea typeface="Times New Roman" pitchFamily="34" charset="-122"/>
+                <a:cs typeface="Times New Roman" pitchFamily="34" charset="-120"/>
+              </a:rPr>
+              <a:t>Define climate.</a:t>
+            </a:r>
+            <a:endParaRPr lang="en-US" sz="4000" dirty="0"/>
+          </a:p>
+        </p:txBody>
+      </p:sp>
+      <p:sp>
+        <p:nvSpPr>
+          <p:cNvPr id="25" name="Slide Number Placeholder 0"/>
+          <p:cNvSpPr>
+            <a:spLocks noGrp="1"/>
+          </p:cNvSpPr>
+          <p:nvPr>
+            <p:ph type="sldNum" sz="quarter" idx="4294967295"/>
+          </p:nvPr>
+        </p:nvSpPr>
+        <p:spPr>
+          <a:xfrm>
+            <a:off x="27432" y="91440"/>
+            <a:ext cx="585216" cy="475488"/>
+          </a:xfrm>
+          <a:prstGeom prst="rect">
+            <a:avLst/>
+          </a:prstGeom>
+          <a:extLst>
+            <a:ext uri="{C572A759-6A51-4108-AA02-DFA0A04FC94B}">
+              <ma14:wrappingTextBoxFlag xmlns:ma14="http://schemas.microsoft.com/office/mac/drawingml/2011/main" val="0"/>
+            </a:ext>
+          </a:extLst>
+        </p:spPr>
+        <p:txBody>
+          <a:bodyPr/>
+          <a:lstStyle>
+            <a:lvl1pPr>
+              <a:defRPr sz="2000">
+                <a:solidFill>
+                  <a:srgbClr val="FFFFFF"/>
+                </a:solidFill>
+                <a:latin typeface="Calibri"/>
+                <a:ea typeface="Calibri"/>
+                <a:cs typeface="Calibri"/>
+              </a:defRPr>
+            </a:lvl1pPr>
+          </a:lstStyle>
+          <a:p>
+            <a:pPr algn="ctr"/>
+            <a:fld id="{F7021451-1387-4CA6-816F-3879F97B5CBC}" type="slidenum">
+              <a:rPr b="1" lang="en-US"/>
+              <a:t>62</a:t>
+            </a:fld>
+            <a:endParaRPr lang="en-US"/>
+          </a:p>
+        </p:txBody>
+      </p:sp>
+    </p:spTree>
+  </p:cSld>
+  <p:clrMapOvr>
+    <a:masterClrMapping/>
+  </p:clrMapOvr>
+</p:sld>
+</file>
+
+<file path=ppt/slides/slide63.xml><?xml version="1.0" encoding="utf-8"?>
+<p:sld xmlns:a="http://schemas.openxmlformats.org/drawingml/2006/main" xmlns:r="http://schemas.openxmlformats.org/officeDocument/2006/relationships" xmlns:p="http://schemas.openxmlformats.org/presentationml/2006/main">
+  <p:cSld name="Slide 63">
+    <p:spTree>
+      <p:nvGrpSpPr>
+        <p:cNvPr id="1" name=""/>
+        <p:cNvGrpSpPr/>
+        <p:nvPr/>
+      </p:nvGrpSpPr>
+      <p:grpSpPr>
+        <a:xfrm>
+          <a:off x="0" y="0"/>
+          <a:ext cx="0" cy="0"/>
+          <a:chOff x="0" y="0"/>
+          <a:chExt cx="0" cy="0"/>
+        </a:xfrm>
+      </p:grpSpPr>
+      <p:sp>
+        <p:nvSpPr>
+          <p:cNvPr id="2" name="Text 0"/>
+          <p:cNvSpPr/>
+          <p:nvPr/>
+        </p:nvSpPr>
+        <p:spPr>
+          <a:xfrm>
+            <a:off x="457200" y="713232"/>
+            <a:ext cx="11368735" cy="274320"/>
+          </a:xfrm>
+          <a:prstGeom prst="rect">
+            <a:avLst/>
+          </a:prstGeom>
+          <a:noFill/>
+          <a:ln/>
+        </p:spPr>
+        <p:txBody>
+          <a:bodyPr wrap="square" lIns="0" tIns="0" rIns="0" bIns="0" rtlCol="0" anchor="ctr"/>
+          <a:lstStyle/>
+          <a:p>
+            <a:pPr algn="r" indent="0" marL="0">
+              <a:buNone/>
+            </a:pPr>
+            <a:r>
+              <a:rPr lang="en-US" sz="1400" b="1" dirty="0">
+                <a:solidFill>
+                  <a:srgbClr val="1C3F6E"/>
+                </a:solidFill>
+                <a:latin typeface="Calibri" pitchFamily="34" charset="0"/>
+                <a:ea typeface="Calibri" pitchFamily="34" charset="-122"/>
+                <a:cs typeface="Calibri" pitchFamily="34" charset="-120"/>
+              </a:rPr>
+              <a:t>NEXT LESSON</a:t>
+            </a:r>
+            <a:endParaRPr lang="en-US" sz="1400" dirty="0"/>
+          </a:p>
+        </p:txBody>
+      </p:sp>
+      <p:pic>
+        <p:nvPicPr>
+          <p:cNvPr id="3" name="Image 0" descr="/home/claude/f4/img/minesec_sheet.png">    </p:cNvPr>
+          <p:cNvPicPr>
+            <a:picLocks noChangeAspect="1"/>
+          </p:cNvPicPr>
+          <p:nvPr/>
+        </p:nvPicPr>
+        <p:blipFill>
+          <a:blip r:embed="rId1"/>
+          <a:stretch>
+            <a:fillRect/>
+          </a:stretch>
+        </p:blipFill>
+        <p:spPr>
+          <a:xfrm>
+            <a:off x="0" y="658368"/>
+            <a:ext cx="5120640" cy="5833872"/>
+          </a:xfrm>
+          <a:prstGeom prst="rect">
+            <a:avLst/>
+          </a:prstGeom>
+        </p:spPr>
+      </p:pic>
+      <p:sp>
+        <p:nvSpPr>
+          <p:cNvPr id="4" name="Text 1"/>
+          <p:cNvSpPr/>
+          <p:nvPr/>
+        </p:nvSpPr>
+        <p:spPr>
+          <a:xfrm>
+            <a:off x="5349240" y="1005840"/>
+            <a:ext cx="6522415" cy="731520"/>
+          </a:xfrm>
+          <a:prstGeom prst="rect">
+            <a:avLst/>
+          </a:prstGeom>
+          <a:noFill/>
+          <a:ln/>
+        </p:spPr>
+        <p:txBody>
+          <a:bodyPr wrap="square" lIns="0" tIns="0" rIns="0" bIns="0" rtlCol="0" anchor="ctr">
+            <a:normAutofit/>
+          </a:bodyPr>
+          <a:lstStyle/>
+          <a:p>
+            <a:pPr algn="ctr" indent="0" marL="0">
+              <a:buNone/>
+            </a:pPr>
+            <a:r>
+              <a:rPr lang="en-US" sz="3600" b="1" dirty="0">
+                <a:solidFill>
+                  <a:srgbClr val="990011"/>
+                </a:solidFill>
+                <a:latin typeface="Times New Roman" pitchFamily="34" charset="0"/>
+                <a:ea typeface="Times New Roman" pitchFamily="34" charset="-122"/>
+                <a:cs typeface="Times New Roman" pitchFamily="34" charset="-120"/>
+              </a:rPr>
+              <a:t>Next Lesson</a:t>
+            </a:r>
+            <a:endParaRPr lang="en-US" sz="3600" dirty="0"/>
+          </a:p>
+        </p:txBody>
+      </p:sp>
+      <p:sp>
+        <p:nvSpPr>
+          <p:cNvPr id="5" name="Text 2"/>
+          <p:cNvSpPr/>
+          <p:nvPr/>
+        </p:nvSpPr>
+        <p:spPr>
+          <a:xfrm>
+            <a:off x="5349240" y="1783080"/>
+            <a:ext cx="6522415" cy="4663440"/>
+          </a:xfrm>
+          <a:prstGeom prst="rect">
+            <a:avLst/>
+          </a:prstGeom>
+          <a:noFill/>
+          <a:ln/>
+        </p:spPr>
+        <p:txBody>
+          <a:bodyPr wrap="square" lIns="0" tIns="0" rIns="0" bIns="0" rtlCol="0" anchor="ctr"/>
+          <a:lstStyle/>
+          <a:p>
+            <a:pPr algn="ctr" indent="0" marL="0">
+              <a:spcAft>
+                <a:spcPts val="800"/>
+              </a:spcAft>
+              <a:buNone/>
+            </a:pPr>
+            <a:r>
+              <a:rPr lang="en-US" sz="4000" b="1" dirty="0">
+                <a:solidFill>
+                  <a:srgbClr val="111111"/>
+                </a:solidFill>
+                <a:latin typeface="Times New Roman" pitchFamily="34" charset="0"/>
+                <a:ea typeface="Times New Roman" pitchFamily="34" charset="-122"/>
+                <a:cs typeface="Times New Roman" pitchFamily="34" charset="-120"/>
+              </a:rPr>
+              <a:t>Our next lesson will be on:</a:t>
+            </a:r>
+            <a:endParaRPr lang="en-US" sz="4000" dirty="0"/>
+          </a:p>
+          <a:p>
+            <a:pPr algn="ctr" indent="0" marL="0">
+              <a:spcAft>
+                <a:spcPts val="800"/>
+              </a:spcAft>
+              <a:buNone/>
+            </a:pPr>
+            <a:r>
+              <a:rPr lang="en-US" sz="4000" b="1" dirty="0">
+                <a:solidFill>
+                  <a:srgbClr val="990011"/>
+                </a:solidFill>
+                <a:latin typeface="Times New Roman" pitchFamily="34" charset="0"/>
+                <a:ea typeface="Times New Roman" pitchFamily="34" charset="-122"/>
+                <a:cs typeface="Times New Roman" pitchFamily="34" charset="-120"/>
+              </a:rPr>
+              <a:t>Lesson 19: Meaning of Climate and Köppen's Classification</a:t>
+            </a:r>
+            <a:endParaRPr lang="en-US" sz="4000" dirty="0"/>
+          </a:p>
+        </p:txBody>
+      </p:sp>
+      <p:sp>
+        <p:nvSpPr>
+          <p:cNvPr id="25" name="Slide Number Placeholder 0"/>
+          <p:cNvSpPr>
+            <a:spLocks noGrp="1"/>
+          </p:cNvSpPr>
+          <p:nvPr>
+            <p:ph type="sldNum" sz="quarter" idx="4294967295"/>
+          </p:nvPr>
+        </p:nvSpPr>
+        <p:spPr>
+          <a:xfrm>
+            <a:off x="27432" y="91440"/>
+            <a:ext cx="585216" cy="475488"/>
+          </a:xfrm>
+          <a:prstGeom prst="rect">
+            <a:avLst/>
+          </a:prstGeom>
+          <a:extLst>
+            <a:ext uri="{C572A759-6A51-4108-AA02-DFA0A04FC94B}">
+              <ma14:wrappingTextBoxFlag xmlns:ma14="http://schemas.microsoft.com/office/mac/drawingml/2011/main" val="0"/>
+            </a:ext>
+          </a:extLst>
+        </p:spPr>
+        <p:txBody>
+          <a:bodyPr/>
+          <a:lstStyle>
+            <a:lvl1pPr>
+              <a:defRPr sz="2000">
+                <a:solidFill>
+                  <a:srgbClr val="FFFFFF"/>
+                </a:solidFill>
+                <a:latin typeface="Calibri"/>
+                <a:ea typeface="Calibri"/>
+                <a:cs typeface="Calibri"/>
+              </a:defRPr>
+            </a:lvl1pPr>
+          </a:lstStyle>
+          <a:p>
+            <a:pPr algn="ctr"/>
+            <a:fld id="{F7021451-1387-4CA6-816F-3879F97B5CBC}" type="slidenum">
+              <a:rPr b="1" lang="en-US"/>
+              <a:t>63</a:t>
+            </a:fld>
+            <a:endParaRPr lang="en-US"/>
+          </a:p>
+        </p:txBody>
+      </p:sp>
+    </p:spTree>
+  </p:cSld>
+  <p:clrMapOvr>
+    <a:masterClrMapping/>
+  </p:clrMapOvr>
+</p:sld>
+</file>
+
+<file path=ppt/slides/slide64.xml><?xml version="1.0" encoding="utf-8"?>
+<p:sld xmlns:a="http://schemas.openxmlformats.org/drawingml/2006/main" xmlns:r="http://schemas.openxmlformats.org/officeDocument/2006/relationships" xmlns:p="http://schemas.openxmlformats.org/presentationml/2006/main">
+  <p:cSld name="Slide 64">
+    <p:spTree>
+      <p:nvGrpSpPr>
+        <p:cNvPr id="1" name=""/>
+        <p:cNvGrpSpPr/>
+        <p:nvPr/>
+      </p:nvGrpSpPr>
+      <p:grpSpPr>
+        <a:xfrm>
+          <a:off x="0" y="0"/>
+          <a:ext cx="0" cy="0"/>
+          <a:chOff x="0" y="0"/>
+          <a:chExt cx="0" cy="0"/>
+        </a:xfrm>
+      </p:grpSpPr>
+      <p:sp>
+        <p:nvSpPr>
+          <p:cNvPr id="2" name="Text 0"/>
+          <p:cNvSpPr/>
+          <p:nvPr/>
+        </p:nvSpPr>
+        <p:spPr>
+          <a:xfrm>
+            <a:off x="457200" y="713232"/>
+            <a:ext cx="11368735" cy="274320"/>
+          </a:xfrm>
+          <a:prstGeom prst="rect">
+            <a:avLst/>
+          </a:prstGeom>
+          <a:noFill/>
+          <a:ln/>
+        </p:spPr>
+        <p:txBody>
+          <a:bodyPr wrap="square" lIns="0" tIns="0" rIns="0" bIns="0" rtlCol="0" anchor="ctr"/>
+          <a:lstStyle/>
+          <a:p>
+            <a:pPr algn="r" indent="0" marL="0">
+              <a:buNone/>
+            </a:pPr>
+            <a:r>
+              <a:rPr lang="en-US" sz="1400" b="1" dirty="0">
+                <a:solidFill>
+                  <a:srgbClr val="1C3F6E"/>
+                </a:solidFill>
+                <a:latin typeface="Calibri" pitchFamily="34" charset="0"/>
+                <a:ea typeface="Calibri" pitchFamily="34" charset="-122"/>
+                <a:cs typeface="Calibri" pitchFamily="34" charset="-120"/>
+              </a:rPr>
+              <a:t>BILINGUAL GAME</a:t>
+            </a:r>
+            <a:endParaRPr lang="en-US" sz="1400" dirty="0"/>
+          </a:p>
+        </p:txBody>
+      </p:sp>
+      <p:sp>
+        <p:nvSpPr>
+          <p:cNvPr id="3" name="Text 1"/>
+          <p:cNvSpPr/>
+          <p:nvPr/>
+        </p:nvSpPr>
+        <p:spPr>
+          <a:xfrm>
+            <a:off x="457200" y="1005840"/>
+            <a:ext cx="11277295" cy="731520"/>
+          </a:xfrm>
+          <a:prstGeom prst="rect">
+            <a:avLst/>
+          </a:prstGeom>
+          <a:noFill/>
+          <a:ln/>
+        </p:spPr>
+        <p:txBody>
+          <a:bodyPr wrap="square" lIns="0" tIns="0" rIns="0" bIns="0" rtlCol="0" anchor="ctr"/>
+          <a:lstStyle/>
+          <a:p>
+            <a:pPr algn="ctr" indent="0" marL="0">
+              <a:buNone/>
+            </a:pPr>
+            <a:r>
+              <a:rPr lang="en-US" sz="3600" b="1" dirty="0">
+                <a:solidFill>
+                  <a:srgbClr val="990011"/>
+                </a:solidFill>
+                <a:latin typeface="Times New Roman" pitchFamily="34" charset="0"/>
+                <a:ea typeface="Times New Roman" pitchFamily="34" charset="-122"/>
+                <a:cs typeface="Times New Roman" pitchFamily="34" charset="-120"/>
+              </a:rPr>
               <a:t>Bilingual Game (Jeu Bilingue)</a:t>
             </a:r>
             <a:endParaRPr lang="en-US" sz="3600" dirty="0"/>
@@ -21963,7 +23194,7 @@
       </p:sp>
       <p:graphicFrame>
         <p:nvGraphicFramePr>
-          <p:cNvPr id="62" name="Table 0"/>
+          <p:cNvPr id="65" name="Table 0"/>
           <p:cNvGraphicFramePr>
             <a:graphicFrameLocks noGrp="1"/>
           </p:cNvGraphicFramePr>
@@ -22999,7 +24230,7 @@
             <a:pPr algn="ctr"/>
             <a:fld id="{F7021451-1387-4CA6-816F-3879F97B5CBC}" type="slidenum">
               <a:rPr b="1" lang="en-US"/>
-              <a:t>61</a:t>
+              <a:t>64</a:t>
             </a:fld>
             <a:endParaRPr lang="en-US"/>
           </a:p>
@@ -23013,9 +24244,9 @@
 </p:sld>
 </file>
 
-<file path=ppt/slides/slide62.xml><?xml version="1.0" encoding="utf-8"?>
+<file path=ppt/slides/slide65.xml><?xml version="1.0" encoding="utf-8"?>
 <p:sld xmlns:a="http://schemas.openxmlformats.org/drawingml/2006/main" xmlns:r="http://schemas.openxmlformats.org/officeDocument/2006/relationships" xmlns:p="http://schemas.openxmlformats.org/presentationml/2006/main">
-  <p:cSld name="Slide 62">
+  <p:cSld name="Slide 65">
     <p:spTree>
       <p:nvGrpSpPr>
         <p:cNvPr id="1" name=""/>
@@ -23110,7 +24341,7 @@
       </p:sp>
       <p:graphicFrame>
         <p:nvGraphicFramePr>
-          <p:cNvPr id="63" name="Table 0"/>
+          <p:cNvPr id="66" name="Table 0"/>
           <p:cNvGraphicFramePr>
             <a:graphicFrameLocks noGrp="1"/>
           </p:cNvGraphicFramePr>
@@ -23732,7 +24963,7 @@
             <a:pPr algn="ctr"/>
             <a:fld id="{F7021451-1387-4CA6-816F-3879F97B5CBC}" type="slidenum">
               <a:rPr b="1" lang="en-US"/>
-              <a:t>62</a:t>
+              <a:t>65</a:t>
             </a:fld>
             <a:endParaRPr lang="en-US"/>
           </a:p>
@@ -23746,9 +24977,9 @@
 </p:sld>
 </file>
 
-<file path=ppt/slides/slide63.xml><?xml version="1.0" encoding="utf-8"?>
+<file path=ppt/slides/slide66.xml><?xml version="1.0" encoding="utf-8"?>
 <p:sld xmlns:a="http://schemas.openxmlformats.org/drawingml/2006/main" xmlns:r="http://schemas.openxmlformats.org/officeDocument/2006/relationships" xmlns:p="http://schemas.openxmlformats.org/presentationml/2006/main">
-  <p:cSld name="Slide 63">
+  <p:cSld name="Slide 66">
     <p:spTree>
       <p:nvGrpSpPr>
         <p:cNvPr id="1" name=""/>
@@ -23843,7 +25074,7 @@
       </p:sp>
       <p:graphicFrame>
         <p:nvGraphicFramePr>
-          <p:cNvPr id="64" name="Table 0"/>
+          <p:cNvPr id="67" name="Table 0"/>
           <p:cNvGraphicFramePr>
             <a:graphicFrameLocks noGrp="1"/>
           </p:cNvGraphicFramePr>
@@ -23953,7 +25184,7 @@
                           <a:ea typeface="Calibri" pitchFamily="34" charset="-122"/>
                           <a:cs typeface="Calibri" pitchFamily="34" charset="-120"/>
                         </a:rPr>
-                        <a:t>DEFINITIONS; Meaning and Characteristics of Air Masses; Development of Air Masses; Classification and Examples; Types and Movements of Air Masses; Air Masses Affecting Cameroon and West Africa.</a:t>
+                        <a:t>DEFINITIONS; Meaning and Characteristics of Air Masses; Development of Air Masses; The Two Letters; Examples; Types and Movements of Air Masses; Air Masses Affecting Cameroon and West Africa.</a:t>
                       </a:r>
                       <a:endParaRPr lang="en-US" sz="1600" dirty="0">
                         <a:latin typeface="Calibri" charset="0"/>
@@ -24603,7 +25834,7 @@
             <a:pPr algn="ctr"/>
             <a:fld id="{F7021451-1387-4CA6-816F-3879F97B5CBC}" type="slidenum">
               <a:rPr b="1" lang="en-US"/>
-              <a:t>63</a:t>
+              <a:t>66</a:t>
             </a:fld>
             <a:endParaRPr lang="en-US"/>
           </a:p>
@@ -24617,9 +25848,9 @@
 </p:sld>
 </file>
 
-<file path=ppt/slides/slide64.xml><?xml version="1.0" encoding="utf-8"?>
+<file path=ppt/slides/slide67.xml><?xml version="1.0" encoding="utf-8"?>
 <p:sld xmlns:a="http://schemas.openxmlformats.org/drawingml/2006/main" xmlns:r="http://schemas.openxmlformats.org/officeDocument/2006/relationships" xmlns:p="http://schemas.openxmlformats.org/presentationml/2006/main">
-  <p:cSld name="Slide 64">
+  <p:cSld name="Slide 67">
     <p:spTree>
       <p:nvGrpSpPr>
         <p:cNvPr id="1" name=""/>
@@ -24928,7 +26159,7 @@
             <a:pPr algn="ctr"/>
             <a:fld id="{F7021451-1387-4CA6-816F-3879F97B5CBC}" type="slidenum">
               <a:rPr b="1" lang="en-US"/>
-              <a:t>64</a:t>
+              <a:t>67</a:t>
             </a:fld>
             <a:endParaRPr lang="en-US"/>
           </a:p>
@@ -24942,9 +26173,9 @@
 </p:sld>
 </file>
 
-<file path=ppt/slides/slide65.xml><?xml version="1.0" encoding="utf-8"?>
+<file path=ppt/slides/slide68.xml><?xml version="1.0" encoding="utf-8"?>
 <p:sld xmlns:a="http://schemas.openxmlformats.org/drawingml/2006/main" xmlns:r="http://schemas.openxmlformats.org/officeDocument/2006/relationships" xmlns:p="http://schemas.openxmlformats.org/presentationml/2006/main">
-  <p:cSld name="Slide 65">
+  <p:cSld name="Slide 68">
     <p:spTree>
       <p:nvGrpSpPr>
         <p:cNvPr id="1" name=""/>
@@ -25232,7 +26463,7 @@
             <a:pPr algn="ctr"/>
             <a:fld id="{F7021451-1387-4CA6-816F-3879F97B5CBC}" type="slidenum">
               <a:rPr b="1" lang="en-US"/>
-              <a:t>65</a:t>
+              <a:t>68</a:t>
             </a:fld>
             <a:endParaRPr lang="en-US"/>
           </a:p>

</xml_diff>